<commit_message>
docs: redraw the DDR pool path as AS-IS versus TO-BE
Show decode cards, the queue inside the master, and the bus into the DDR pool. AS-IS sends every swap across the control plane before DMA. TO-BE keeps the offset on the card and leaves the master for allocate, free, and lease refresh.

Co-authored-by: 69515164-rgb <69515164-rgb@users.noreply.github.com>
</commit_message>
<xml_diff>
--- a/docs/ddr-pool-master-swap.pptx
+++ b/docs/ddr-pool-master-swap.pptx
@@ -502,7 +502,7 @@
           <a:lstStyle/>
           <a:p>
             <a:r>
-              <a:t>这页描述的是一个为拉高 batch 而把 DDR 池做成跨卡共享、并由 Master 发放池内偏移的设计。数据面是 Decode 卡经总线对 DDR 池做 DMA，KV 字节不进 Master。控制面每次如果都走，Decode 送出块 id、字节数、换入或换出；Master 返回池内偏移、长度、租约。地址写进卡上块表之后，租约未到期且块未被释放时，换入换出只查块表。有必要再问 Master 的是三类事件：新块第一次进池、块从池中释放、租约到期。估算：4 MB / 64 GB/s 约 0.06 ms。不排队的一次 RPC 按 0.2 ms。一步 20 ms、batch 32、每请求换入换出各一块时，单卡约 3200 次/秒；8 卡约 2.6 万次/秒，单线程 Master 按 50 us 服务约 2 万次/秒，队列会涨。当前 vLLM OffloadingConnector 与 SGLang HiCache L2 的 host DDR 是进程内块表，路径上没有这跳 Master。MooncakeStore 的 PutStart / GetReplicaList 用在跨节点对象池的写入和未命中读取，不是每个 decode step 的换入换出。</a:t>
+              <a:t>AS-IS 画的是为拉高 batch，把 DDR 池做成跨卡共享，并且每次换入换出都向 Master 要地址。三张 Decode 卡经控制面把块 id、字节数、方向送入 Master 内部队列。Master 出队时返回池内偏移、长度、租约。总线平面的 DMA 由 Decode 卡发往直挂的 DDR 池，发生在出队之后。KV 字节不进入 Master。估算：4 MB / 64 GB/s 约 0.06 ms；不排队的往返按 0.2 ms。一步 20 ms、batch 32、每请求换入换出各一块，单卡约 3200 次/秒，8 卡约 2.6 万次/秒。单线程按 50 us 服务约 2 万次/秒，队列变长。TO-BE 中块表保存偏移和租约。热路径是 Decode 卡到 DDR 池的总线 DMA，Master 队列不在这条路径上。控制面只在新块第一次进池、块释放、租约到期时进入 Master。当前 vLLM OffloadingConnector 和 SGLang HiCache L2 的本机 host DDR 已经是进程内块表，形态接近右侧，没有左侧这跳。</a:t>
             </a:r>
           </a:p>
         </p:txBody>
@@ -3560,7 +3560,7 @@
         <p:spPr>
           <a:xfrm>
             <a:off x="384048" y="128016"/>
-            <a:ext cx="9509760" cy="201168"/>
+            <a:ext cx="8778240" cy="201168"/>
           </a:xfrm>
           <a:prstGeom prst="rect">
             <a:avLst/>
@@ -3588,7 +3588,7 @@
                 <a:ea typeface="Microsoft YaHei"/>
                 <a:cs typeface="Microsoft YaHei"/>
               </a:rPr>
-              <a:t>Decode    ·    DDR 池直挂总线    ·    拉高 batch</a:t>
+              <a:t>拉高 batch    ·    控制面海军蓝    ·    总线平面青色</a:t>
             </a:r>
           </a:p>
         </p:txBody>
@@ -3602,7 +3602,7 @@
         <p:spPr>
           <a:xfrm>
             <a:off x="384048" y="329184"/>
-            <a:ext cx="10607040" cy="365760"/>
+            <a:ext cx="10607040" cy="347472"/>
           </a:xfrm>
           <a:prstGeom prst="rect">
             <a:avLst/>
@@ -3630,7 +3630,7 @@
                 <a:ea typeface="Microsoft YaHei"/>
                 <a:cs typeface="Microsoft YaHei"/>
               </a:rPr>
-              <a:t>每次都问 Master，换入换出会被控制面堵住</a:t>
+              <a:t>热路径从 Master 排队，改成直走总线</a:t>
             </a:r>
           </a:p>
         </p:txBody>
@@ -3643,8 +3643,8 @@
         </p:nvSpPr>
         <p:spPr>
           <a:xfrm>
-            <a:off x="10424160" y="146304"/>
-            <a:ext cx="1371600" cy="201168"/>
+            <a:off x="10378440" y="146304"/>
+            <a:ext cx="1417320" cy="201168"/>
           </a:xfrm>
           <a:prstGeom prst="rect">
             <a:avLst/>
@@ -3685,8 +3685,8 @@
         </p:nvSpPr>
         <p:spPr>
           <a:xfrm>
-            <a:off x="384048" y="768096"/>
-            <a:ext cx="11430000" cy="365760"/>
+            <a:off x="384048" y="749808"/>
+            <a:ext cx="11430000" cy="329184"/>
           </a:xfrm>
           <a:prstGeom prst="roundRect">
             <a:avLst/>
@@ -3728,8 +3728,8 @@
         </p:nvSpPr>
         <p:spPr>
           <a:xfrm>
-            <a:off x="512064" y="768096"/>
-            <a:ext cx="11173968" cy="365760"/>
+            <a:off x="512064" y="749808"/>
+            <a:ext cx="11173968" cy="329184"/>
           </a:xfrm>
           <a:prstGeom prst="rect">
             <a:avLst/>
@@ -3757,7 +3757,7 @@
                 <a:ea typeface="Microsoft YaHei"/>
                 <a:cs typeface="Microsoft YaHei"/>
               </a:rPr>
-              <a:t>HBM 只留当前 batch 的工作集。其余 KV 在直挂总线的 DDR 池。KV 字节走 DMA，Master 只发池内偏移和租约。</a:t>
+              <a:t>左为 AS-IS：每次 swap 进 Master 排队，出队后才 DMA。右为 TO-BE：块表已有偏移，热路径只走总线。</a:t>
             </a:r>
           </a:p>
         </p:txBody>
@@ -3770,8 +3770,8 @@
         </p:nvSpPr>
         <p:spPr>
           <a:xfrm>
-            <a:off x="384048" y="1243584"/>
-            <a:ext cx="5632704" cy="310896"/>
+            <a:off x="365760" y="1170432"/>
+            <a:ext cx="5559552" cy="292608"/>
           </a:xfrm>
           <a:prstGeom prst="roundRect">
             <a:avLst/>
@@ -3813,8 +3813,8 @@
         </p:nvSpPr>
         <p:spPr>
           <a:xfrm>
-            <a:off x="512064" y="1243584"/>
-            <a:ext cx="5376672" cy="310896"/>
+            <a:off x="475488" y="1170432"/>
+            <a:ext cx="5340096" cy="292608"/>
           </a:xfrm>
           <a:prstGeom prst="rect">
             <a:avLst/>
@@ -3842,7 +3842,7 @@
                 <a:ea typeface="Microsoft YaHei"/>
                 <a:cs typeface="Microsoft YaHei"/>
               </a:rPr>
-              <a:t>每次 swap 都问    控制面堵住 DMA</a:t>
+              <a:t>AS-IS    每次 swap 都进 Master 排队</a:t>
             </a:r>
           </a:p>
         </p:txBody>
@@ -3855,8 +3855,8 @@
         </p:nvSpPr>
         <p:spPr>
           <a:xfrm>
-            <a:off x="6181344" y="1243584"/>
-            <a:ext cx="5632704" cy="310896"/>
+            <a:off x="6272784" y="1170432"/>
+            <a:ext cx="5559552" cy="292608"/>
           </a:xfrm>
           <a:prstGeom prst="roundRect">
             <a:avLst/>
@@ -3898,8 +3898,8 @@
         </p:nvSpPr>
         <p:spPr>
           <a:xfrm>
-            <a:off x="6309359" y="1243584"/>
-            <a:ext cx="5376672" cy="310896"/>
+            <a:off x="6382512" y="1170432"/>
+            <a:ext cx="5340096" cy="292608"/>
           </a:xfrm>
           <a:prstGeom prst="rect">
             <a:avLst/>
@@ -3927,7 +3927,7 @@
                 <a:ea typeface="Microsoft YaHei"/>
                 <a:cs typeface="Microsoft YaHei"/>
               </a:rPr>
-              <a:t>块还在池里    只查卡上的块表</a:t>
+              <a:t>TO-BE    热路径只走总线平面</a:t>
             </a:r>
           </a:p>
         </p:txBody>
@@ -3940,8 +3940,8 @@
         </p:nvSpPr>
         <p:spPr>
           <a:xfrm>
-            <a:off x="530352" y="1664208"/>
-            <a:ext cx="5340096" cy="658368"/>
+            <a:off x="475488" y="1572768"/>
+            <a:ext cx="1874519" cy="621792"/>
           </a:xfrm>
           <a:prstGeom prst="roundRect">
             <a:avLst/>
@@ -3985,8 +3985,8 @@
         </p:nvSpPr>
         <p:spPr>
           <a:xfrm>
-            <a:off x="640080" y="1719072"/>
-            <a:ext cx="5120640" cy="292608"/>
+            <a:off x="530352" y="1609344"/>
+            <a:ext cx="1764791" cy="256032"/>
           </a:xfrm>
           <a:prstGeom prst="rect">
             <a:avLst/>
@@ -4006,7 +4006,7 @@
               </a:spcAft>
             </a:pPr>
             <a:r>
-              <a:rPr sz="1500" b="1">
+              <a:rPr sz="1200" b="1">
                 <a:solidFill>
                   <a:srgbClr val="0E2A47"/>
                 </a:solidFill>
@@ -4014,7 +4014,7 @@
                 <a:ea typeface="Microsoft YaHei"/>
                 <a:cs typeface="Microsoft YaHei"/>
               </a:rPr>
-              <a:t>Decode 卡</a:t>
+              <a:t>Decode 卡 1</a:t>
             </a:r>
           </a:p>
         </p:txBody>
@@ -4027,8 +4027,8 @@
         </p:nvSpPr>
         <p:spPr>
           <a:xfrm>
-            <a:off x="640080" y="1993392"/>
-            <a:ext cx="5120640" cy="256031"/>
+            <a:off x="530352" y="1847088"/>
+            <a:ext cx="1764791" cy="292608"/>
           </a:xfrm>
           <a:prstGeom prst="rect">
             <a:avLst/>
@@ -4036,7 +4036,990 @@
           <a:noFill/>
         </p:spPr>
         <p:txBody>
-          <a:bodyPr wrap="square" lIns="0" rIns="0" tIns="0" bIns="0" anchor="t"/>
+          <a:bodyPr wrap="square" lIns="0" rIns="0" tIns="0" bIns="0" anchor="ctr"/>
+          <a:lstStyle/>
+          <a:p>
+            <a:pPr algn="ctr">
+              <a:spcBef>
+                <a:spcPts val="0"/>
+              </a:spcBef>
+              <a:spcAft>
+                <a:spcPts val="0"/>
+              </a:spcAft>
+            </a:pPr>
+            <a:r>
+              <a:rPr sz="1100" b="0">
+                <a:solidFill>
+                  <a:srgbClr val="5A636E"/>
+                </a:solidFill>
+                <a:latin typeface="Microsoft YaHei"/>
+                <a:ea typeface="Microsoft YaHei"/>
+                <a:cs typeface="Microsoft YaHei"/>
+              </a:rPr>
+              <a:t>换入 / 换出</a:t>
+            </a:r>
+          </a:p>
+        </p:txBody>
+      </p:sp>
+      <p:sp>
+        <p:nvSpPr>
+          <p:cNvPr id="15" name="Right Arrow 14"/>
+          <p:cNvSpPr/>
+          <p:nvPr/>
+        </p:nvSpPr>
+        <p:spPr>
+          <a:xfrm>
+            <a:off x="2414016" y="1755648"/>
+            <a:ext cx="420624" cy="219456"/>
+          </a:xfrm>
+          <a:prstGeom prst="rightArrow">
+            <a:avLst/>
+          </a:prstGeom>
+          <a:solidFill>
+            <a:srgbClr val="0E2A47"/>
+          </a:solidFill>
+          <a:ln>
+            <a:noFill/>
+          </a:ln>
+        </p:spPr>
+        <p:style>
+          <a:lnRef idx="1">
+            <a:schemeClr val="accent1"/>
+          </a:lnRef>
+          <a:fillRef idx="3">
+            <a:schemeClr val="accent1"/>
+          </a:fillRef>
+          <a:effectRef idx="2">
+            <a:schemeClr val="accent1"/>
+          </a:effectRef>
+          <a:fontRef idx="minor">
+            <a:schemeClr val="lt1"/>
+          </a:fontRef>
+        </p:style>
+        <p:txBody>
+          <a:bodyPr rtlCol="0" anchor="ctr"/>
+          <a:lstStyle/>
+          <a:p>
+            <a:pPr algn="ctr"/>
+          </a:p>
+        </p:txBody>
+      </p:sp>
+      <p:sp>
+        <p:nvSpPr>
+          <p:cNvPr id="16" name="Rounded Rectangle 15"/>
+          <p:cNvSpPr/>
+          <p:nvPr/>
+        </p:nvSpPr>
+        <p:spPr>
+          <a:xfrm>
+            <a:off x="475488" y="2286000"/>
+            <a:ext cx="1874519" cy="621792"/>
+          </a:xfrm>
+          <a:prstGeom prst="roundRect">
+            <a:avLst/>
+          </a:prstGeom>
+          <a:solidFill>
+            <a:srgbClr val="F4F7FA"/>
+          </a:solidFill>
+          <a:ln w="12700">
+            <a:solidFill>
+              <a:srgbClr val="D6DCE2"/>
+            </a:solidFill>
+          </a:ln>
+        </p:spPr>
+        <p:style>
+          <a:lnRef idx="1">
+            <a:schemeClr val="accent1"/>
+          </a:lnRef>
+          <a:fillRef idx="3">
+            <a:schemeClr val="accent1"/>
+          </a:fillRef>
+          <a:effectRef idx="2">
+            <a:schemeClr val="accent1"/>
+          </a:effectRef>
+          <a:fontRef idx="minor">
+            <a:schemeClr val="lt1"/>
+          </a:fontRef>
+        </p:style>
+        <p:txBody>
+          <a:bodyPr rtlCol="0" anchor="ctr"/>
+          <a:lstStyle/>
+          <a:p>
+            <a:pPr algn="ctr"/>
+          </a:p>
+        </p:txBody>
+      </p:sp>
+      <p:sp>
+        <p:nvSpPr>
+          <p:cNvPr id="17" name="TextBox 16"/>
+          <p:cNvSpPr txBox="1"/>
+          <p:nvPr/>
+        </p:nvSpPr>
+        <p:spPr>
+          <a:xfrm>
+            <a:off x="530352" y="2322576"/>
+            <a:ext cx="1764791" cy="256032"/>
+          </a:xfrm>
+          <a:prstGeom prst="rect">
+            <a:avLst/>
+          </a:prstGeom>
+          <a:noFill/>
+        </p:spPr>
+        <p:txBody>
+          <a:bodyPr wrap="square" lIns="0" rIns="0" tIns="0" bIns="0" anchor="ctr"/>
+          <a:lstStyle/>
+          <a:p>
+            <a:pPr algn="ctr">
+              <a:spcBef>
+                <a:spcPts val="0"/>
+              </a:spcBef>
+              <a:spcAft>
+                <a:spcPts val="0"/>
+              </a:spcAft>
+            </a:pPr>
+            <a:r>
+              <a:rPr sz="1200" b="1">
+                <a:solidFill>
+                  <a:srgbClr val="0E2A47"/>
+                </a:solidFill>
+                <a:latin typeface="Microsoft YaHei"/>
+                <a:ea typeface="Microsoft YaHei"/>
+                <a:cs typeface="Microsoft YaHei"/>
+              </a:rPr>
+              <a:t>Decode 卡 2</a:t>
+            </a:r>
+          </a:p>
+        </p:txBody>
+      </p:sp>
+      <p:sp>
+        <p:nvSpPr>
+          <p:cNvPr id="18" name="TextBox 17"/>
+          <p:cNvSpPr txBox="1"/>
+          <p:nvPr/>
+        </p:nvSpPr>
+        <p:spPr>
+          <a:xfrm>
+            <a:off x="530352" y="2560320"/>
+            <a:ext cx="1764791" cy="292608"/>
+          </a:xfrm>
+          <a:prstGeom prst="rect">
+            <a:avLst/>
+          </a:prstGeom>
+          <a:noFill/>
+        </p:spPr>
+        <p:txBody>
+          <a:bodyPr wrap="square" lIns="0" rIns="0" tIns="0" bIns="0" anchor="ctr"/>
+          <a:lstStyle/>
+          <a:p>
+            <a:pPr algn="ctr">
+              <a:spcBef>
+                <a:spcPts val="0"/>
+              </a:spcBef>
+              <a:spcAft>
+                <a:spcPts val="0"/>
+              </a:spcAft>
+            </a:pPr>
+            <a:r>
+              <a:rPr sz="1100" b="0">
+                <a:solidFill>
+                  <a:srgbClr val="5A636E"/>
+                </a:solidFill>
+                <a:latin typeface="Microsoft YaHei"/>
+                <a:ea typeface="Microsoft YaHei"/>
+                <a:cs typeface="Microsoft YaHei"/>
+              </a:rPr>
+              <a:t>换入 / 换出</a:t>
+            </a:r>
+          </a:p>
+        </p:txBody>
+      </p:sp>
+      <p:sp>
+        <p:nvSpPr>
+          <p:cNvPr id="19" name="Right Arrow 18"/>
+          <p:cNvSpPr/>
+          <p:nvPr/>
+        </p:nvSpPr>
+        <p:spPr>
+          <a:xfrm>
+            <a:off x="2414016" y="2468880"/>
+            <a:ext cx="420624" cy="219456"/>
+          </a:xfrm>
+          <a:prstGeom prst="rightArrow">
+            <a:avLst/>
+          </a:prstGeom>
+          <a:solidFill>
+            <a:srgbClr val="0E2A47"/>
+          </a:solidFill>
+          <a:ln>
+            <a:noFill/>
+          </a:ln>
+        </p:spPr>
+        <p:style>
+          <a:lnRef idx="1">
+            <a:schemeClr val="accent1"/>
+          </a:lnRef>
+          <a:fillRef idx="3">
+            <a:schemeClr val="accent1"/>
+          </a:fillRef>
+          <a:effectRef idx="2">
+            <a:schemeClr val="accent1"/>
+          </a:effectRef>
+          <a:fontRef idx="minor">
+            <a:schemeClr val="lt1"/>
+          </a:fontRef>
+        </p:style>
+        <p:txBody>
+          <a:bodyPr rtlCol="0" anchor="ctr"/>
+          <a:lstStyle/>
+          <a:p>
+            <a:pPr algn="ctr"/>
+          </a:p>
+        </p:txBody>
+      </p:sp>
+      <p:sp>
+        <p:nvSpPr>
+          <p:cNvPr id="20" name="Rounded Rectangle 19"/>
+          <p:cNvSpPr/>
+          <p:nvPr/>
+        </p:nvSpPr>
+        <p:spPr>
+          <a:xfrm>
+            <a:off x="475488" y="2999232"/>
+            <a:ext cx="1874519" cy="621792"/>
+          </a:xfrm>
+          <a:prstGeom prst="roundRect">
+            <a:avLst/>
+          </a:prstGeom>
+          <a:solidFill>
+            <a:srgbClr val="F4F7FA"/>
+          </a:solidFill>
+          <a:ln w="12700">
+            <a:solidFill>
+              <a:srgbClr val="D6DCE2"/>
+            </a:solidFill>
+          </a:ln>
+        </p:spPr>
+        <p:style>
+          <a:lnRef idx="1">
+            <a:schemeClr val="accent1"/>
+          </a:lnRef>
+          <a:fillRef idx="3">
+            <a:schemeClr val="accent1"/>
+          </a:fillRef>
+          <a:effectRef idx="2">
+            <a:schemeClr val="accent1"/>
+          </a:effectRef>
+          <a:fontRef idx="minor">
+            <a:schemeClr val="lt1"/>
+          </a:fontRef>
+        </p:style>
+        <p:txBody>
+          <a:bodyPr rtlCol="0" anchor="ctr"/>
+          <a:lstStyle/>
+          <a:p>
+            <a:pPr algn="ctr"/>
+          </a:p>
+        </p:txBody>
+      </p:sp>
+      <p:sp>
+        <p:nvSpPr>
+          <p:cNvPr id="21" name="TextBox 20"/>
+          <p:cNvSpPr txBox="1"/>
+          <p:nvPr/>
+        </p:nvSpPr>
+        <p:spPr>
+          <a:xfrm>
+            <a:off x="530352" y="3035808"/>
+            <a:ext cx="1764791" cy="256032"/>
+          </a:xfrm>
+          <a:prstGeom prst="rect">
+            <a:avLst/>
+          </a:prstGeom>
+          <a:noFill/>
+        </p:spPr>
+        <p:txBody>
+          <a:bodyPr wrap="square" lIns="0" rIns="0" tIns="0" bIns="0" anchor="ctr"/>
+          <a:lstStyle/>
+          <a:p>
+            <a:pPr algn="ctr">
+              <a:spcBef>
+                <a:spcPts val="0"/>
+              </a:spcBef>
+              <a:spcAft>
+                <a:spcPts val="0"/>
+              </a:spcAft>
+            </a:pPr>
+            <a:r>
+              <a:rPr sz="1200" b="1">
+                <a:solidFill>
+                  <a:srgbClr val="0E2A47"/>
+                </a:solidFill>
+                <a:latin typeface="Microsoft YaHei"/>
+                <a:ea typeface="Microsoft YaHei"/>
+                <a:cs typeface="Microsoft YaHei"/>
+              </a:rPr>
+              <a:t>Decode 卡 N</a:t>
+            </a:r>
+          </a:p>
+        </p:txBody>
+      </p:sp>
+      <p:sp>
+        <p:nvSpPr>
+          <p:cNvPr id="22" name="TextBox 21"/>
+          <p:cNvSpPr txBox="1"/>
+          <p:nvPr/>
+        </p:nvSpPr>
+        <p:spPr>
+          <a:xfrm>
+            <a:off x="530352" y="3273552"/>
+            <a:ext cx="1764791" cy="292608"/>
+          </a:xfrm>
+          <a:prstGeom prst="rect">
+            <a:avLst/>
+          </a:prstGeom>
+          <a:noFill/>
+        </p:spPr>
+        <p:txBody>
+          <a:bodyPr wrap="square" lIns="0" rIns="0" tIns="0" bIns="0" anchor="ctr"/>
+          <a:lstStyle/>
+          <a:p>
+            <a:pPr algn="ctr">
+              <a:spcBef>
+                <a:spcPts val="0"/>
+              </a:spcBef>
+              <a:spcAft>
+                <a:spcPts val="0"/>
+              </a:spcAft>
+            </a:pPr>
+            <a:r>
+              <a:rPr sz="1100" b="0">
+                <a:solidFill>
+                  <a:srgbClr val="5A636E"/>
+                </a:solidFill>
+                <a:latin typeface="Microsoft YaHei"/>
+                <a:ea typeface="Microsoft YaHei"/>
+                <a:cs typeface="Microsoft YaHei"/>
+              </a:rPr>
+              <a:t>换入 / 换出</a:t>
+            </a:r>
+          </a:p>
+        </p:txBody>
+      </p:sp>
+      <p:sp>
+        <p:nvSpPr>
+          <p:cNvPr id="23" name="Right Arrow 22"/>
+          <p:cNvSpPr/>
+          <p:nvPr/>
+        </p:nvSpPr>
+        <p:spPr>
+          <a:xfrm>
+            <a:off x="2414016" y="3182112"/>
+            <a:ext cx="420624" cy="219456"/>
+          </a:xfrm>
+          <a:prstGeom prst="rightArrow">
+            <a:avLst/>
+          </a:prstGeom>
+          <a:solidFill>
+            <a:srgbClr val="0E2A47"/>
+          </a:solidFill>
+          <a:ln>
+            <a:noFill/>
+          </a:ln>
+        </p:spPr>
+        <p:style>
+          <a:lnRef idx="1">
+            <a:schemeClr val="accent1"/>
+          </a:lnRef>
+          <a:fillRef idx="3">
+            <a:schemeClr val="accent1"/>
+          </a:fillRef>
+          <a:effectRef idx="2">
+            <a:schemeClr val="accent1"/>
+          </a:effectRef>
+          <a:fontRef idx="minor">
+            <a:schemeClr val="lt1"/>
+          </a:fontRef>
+        </p:style>
+        <p:txBody>
+          <a:bodyPr rtlCol="0" anchor="ctr"/>
+          <a:lstStyle/>
+          <a:p>
+            <a:pPr algn="ctr"/>
+          </a:p>
+        </p:txBody>
+      </p:sp>
+      <p:sp>
+        <p:nvSpPr>
+          <p:cNvPr id="24" name="Rounded Rectangle 23"/>
+          <p:cNvSpPr/>
+          <p:nvPr/>
+        </p:nvSpPr>
+        <p:spPr>
+          <a:xfrm>
+            <a:off x="2889504" y="1572768"/>
+            <a:ext cx="2907792" cy="2048256"/>
+          </a:xfrm>
+          <a:prstGeom prst="roundRect">
+            <a:avLst/>
+          </a:prstGeom>
+          <a:solidFill>
+            <a:srgbClr val="FFFFFF"/>
+          </a:solidFill>
+          <a:ln w="12700">
+            <a:solidFill>
+              <a:srgbClr val="0E2A47"/>
+            </a:solidFill>
+          </a:ln>
+        </p:spPr>
+        <p:style>
+          <a:lnRef idx="1">
+            <a:schemeClr val="accent1"/>
+          </a:lnRef>
+          <a:fillRef idx="3">
+            <a:schemeClr val="accent1"/>
+          </a:fillRef>
+          <a:effectRef idx="2">
+            <a:schemeClr val="accent1"/>
+          </a:effectRef>
+          <a:fontRef idx="minor">
+            <a:schemeClr val="lt1"/>
+          </a:fontRef>
+        </p:style>
+        <p:txBody>
+          <a:bodyPr rtlCol="0" anchor="ctr"/>
+          <a:lstStyle/>
+          <a:p>
+            <a:pPr algn="ctr"/>
+          </a:p>
+        </p:txBody>
+      </p:sp>
+      <p:sp>
+        <p:nvSpPr>
+          <p:cNvPr id="25" name="TextBox 24"/>
+          <p:cNvSpPr txBox="1"/>
+          <p:nvPr/>
+        </p:nvSpPr>
+        <p:spPr>
+          <a:xfrm>
+            <a:off x="2999232" y="1627632"/>
+            <a:ext cx="2688336" cy="256032"/>
+          </a:xfrm>
+          <a:prstGeom prst="rect">
+            <a:avLst/>
+          </a:prstGeom>
+          <a:noFill/>
+        </p:spPr>
+        <p:txBody>
+          <a:bodyPr wrap="square" lIns="0" rIns="0" tIns="0" bIns="0" anchor="ctr"/>
+          <a:lstStyle/>
+          <a:p>
+            <a:pPr algn="ctr">
+              <a:spcBef>
+                <a:spcPts val="0"/>
+              </a:spcBef>
+              <a:spcAft>
+                <a:spcPts val="0"/>
+              </a:spcAft>
+            </a:pPr>
+            <a:r>
+              <a:rPr sz="1400" b="1">
+                <a:solidFill>
+                  <a:srgbClr val="0E2A47"/>
+                </a:solidFill>
+                <a:latin typeface="Microsoft YaHei"/>
+                <a:ea typeface="Microsoft YaHei"/>
+                <a:cs typeface="Microsoft YaHei"/>
+              </a:rPr>
+              <a:t>Master 节点</a:t>
+            </a:r>
+          </a:p>
+        </p:txBody>
+      </p:sp>
+      <p:sp>
+        <p:nvSpPr>
+          <p:cNvPr id="26" name="TextBox 25"/>
+          <p:cNvSpPr txBox="1"/>
+          <p:nvPr/>
+        </p:nvSpPr>
+        <p:spPr>
+          <a:xfrm>
+            <a:off x="2999232" y="1883664"/>
+            <a:ext cx="2688336" cy="201168"/>
+          </a:xfrm>
+          <a:prstGeom prst="rect">
+            <a:avLst/>
+          </a:prstGeom>
+          <a:noFill/>
+        </p:spPr>
+        <p:txBody>
+          <a:bodyPr wrap="square" lIns="0" rIns="0" tIns="0" bIns="0" anchor="ctr"/>
+          <a:lstStyle/>
+          <a:p>
+            <a:pPr algn="ctr">
+              <a:spcBef>
+                <a:spcPts val="0"/>
+              </a:spcBef>
+              <a:spcAft>
+                <a:spcPts val="0"/>
+              </a:spcAft>
+            </a:pPr>
+            <a:r>
+              <a:rPr sz="1100" b="1">
+                <a:solidFill>
+                  <a:srgbClr val="7A541C"/>
+                </a:solidFill>
+                <a:latin typeface="Microsoft YaHei"/>
+                <a:ea typeface="Microsoft YaHei"/>
+                <a:cs typeface="Microsoft YaHei"/>
+              </a:rPr>
+              <a:t>控制面队列</a:t>
+            </a:r>
+          </a:p>
+        </p:txBody>
+      </p:sp>
+      <p:sp>
+        <p:nvSpPr>
+          <p:cNvPr id="27" name="Rounded Rectangle 26"/>
+          <p:cNvSpPr/>
+          <p:nvPr/>
+        </p:nvSpPr>
+        <p:spPr>
+          <a:xfrm>
+            <a:off x="3017520" y="2121408"/>
+            <a:ext cx="486460" cy="329184"/>
+          </a:xfrm>
+          <a:prstGeom prst="roundRect">
+            <a:avLst/>
+          </a:prstGeom>
+          <a:solidFill>
+            <a:srgbClr val="F8F1E4"/>
+          </a:solidFill>
+          <a:ln>
+            <a:noFill/>
+          </a:ln>
+        </p:spPr>
+        <p:style>
+          <a:lnRef idx="1">
+            <a:schemeClr val="accent1"/>
+          </a:lnRef>
+          <a:fillRef idx="3">
+            <a:schemeClr val="accent1"/>
+          </a:fillRef>
+          <a:effectRef idx="2">
+            <a:schemeClr val="accent1"/>
+          </a:effectRef>
+          <a:fontRef idx="minor">
+            <a:schemeClr val="lt1"/>
+          </a:fontRef>
+        </p:style>
+        <p:txBody>
+          <a:bodyPr rtlCol="0" anchor="ctr"/>
+          <a:lstStyle/>
+          <a:p>
+            <a:pPr algn="ctr"/>
+          </a:p>
+        </p:txBody>
+      </p:sp>
+      <p:sp>
+        <p:nvSpPr>
+          <p:cNvPr id="28" name="TextBox 27"/>
+          <p:cNvSpPr txBox="1"/>
+          <p:nvPr/>
+        </p:nvSpPr>
+        <p:spPr>
+          <a:xfrm>
+            <a:off x="3017520" y="2121408"/>
+            <a:ext cx="486460" cy="329184"/>
+          </a:xfrm>
+          <a:prstGeom prst="rect">
+            <a:avLst/>
+          </a:prstGeom>
+          <a:noFill/>
+        </p:spPr>
+        <p:txBody>
+          <a:bodyPr wrap="square" lIns="0" rIns="0" tIns="0" bIns="0" anchor="ctr"/>
+          <a:lstStyle/>
+          <a:p>
+            <a:pPr algn="ctr">
+              <a:spcBef>
+                <a:spcPts val="0"/>
+              </a:spcBef>
+              <a:spcAft>
+                <a:spcPts val="0"/>
+              </a:spcAft>
+            </a:pPr>
+            <a:r>
+              <a:rPr sz="1100" b="1">
+                <a:solidFill>
+                  <a:srgbClr val="7A541C"/>
+                </a:solidFill>
+                <a:latin typeface="Microsoft YaHei"/>
+                <a:ea typeface="Microsoft YaHei"/>
+                <a:cs typeface="Microsoft YaHei"/>
+              </a:rPr>
+              <a:t>卡1</a:t>
+            </a:r>
+          </a:p>
+        </p:txBody>
+      </p:sp>
+      <p:sp>
+        <p:nvSpPr>
+          <p:cNvPr id="29" name="Rounded Rectangle 28"/>
+          <p:cNvSpPr/>
+          <p:nvPr/>
+        </p:nvSpPr>
+        <p:spPr>
+          <a:xfrm>
+            <a:off x="3558844" y="2121408"/>
+            <a:ext cx="486460" cy="329184"/>
+          </a:xfrm>
+          <a:prstGeom prst="roundRect">
+            <a:avLst/>
+          </a:prstGeom>
+          <a:solidFill>
+            <a:srgbClr val="F8F1E4"/>
+          </a:solidFill>
+          <a:ln>
+            <a:noFill/>
+          </a:ln>
+        </p:spPr>
+        <p:style>
+          <a:lnRef idx="1">
+            <a:schemeClr val="accent1"/>
+          </a:lnRef>
+          <a:fillRef idx="3">
+            <a:schemeClr val="accent1"/>
+          </a:fillRef>
+          <a:effectRef idx="2">
+            <a:schemeClr val="accent1"/>
+          </a:effectRef>
+          <a:fontRef idx="minor">
+            <a:schemeClr val="lt1"/>
+          </a:fontRef>
+        </p:style>
+        <p:txBody>
+          <a:bodyPr rtlCol="0" anchor="ctr"/>
+          <a:lstStyle/>
+          <a:p>
+            <a:pPr algn="ctr"/>
+          </a:p>
+        </p:txBody>
+      </p:sp>
+      <p:sp>
+        <p:nvSpPr>
+          <p:cNvPr id="30" name="TextBox 29"/>
+          <p:cNvSpPr txBox="1"/>
+          <p:nvPr/>
+        </p:nvSpPr>
+        <p:spPr>
+          <a:xfrm>
+            <a:off x="3558844" y="2121408"/>
+            <a:ext cx="486460" cy="329184"/>
+          </a:xfrm>
+          <a:prstGeom prst="rect">
+            <a:avLst/>
+          </a:prstGeom>
+          <a:noFill/>
+        </p:spPr>
+        <p:txBody>
+          <a:bodyPr wrap="square" lIns="0" rIns="0" tIns="0" bIns="0" anchor="ctr"/>
+          <a:lstStyle/>
+          <a:p>
+            <a:pPr algn="ctr">
+              <a:spcBef>
+                <a:spcPts val="0"/>
+              </a:spcBef>
+              <a:spcAft>
+                <a:spcPts val="0"/>
+              </a:spcAft>
+            </a:pPr>
+            <a:r>
+              <a:rPr sz="1100" b="1">
+                <a:solidFill>
+                  <a:srgbClr val="7A541C"/>
+                </a:solidFill>
+                <a:latin typeface="Microsoft YaHei"/>
+                <a:ea typeface="Microsoft YaHei"/>
+                <a:cs typeface="Microsoft YaHei"/>
+              </a:rPr>
+              <a:t>卡2</a:t>
+            </a:r>
+          </a:p>
+        </p:txBody>
+      </p:sp>
+      <p:sp>
+        <p:nvSpPr>
+          <p:cNvPr id="31" name="Rounded Rectangle 30"/>
+          <p:cNvSpPr/>
+          <p:nvPr/>
+        </p:nvSpPr>
+        <p:spPr>
+          <a:xfrm>
+            <a:off x="4100169" y="2121408"/>
+            <a:ext cx="486460" cy="329184"/>
+          </a:xfrm>
+          <a:prstGeom prst="roundRect">
+            <a:avLst/>
+          </a:prstGeom>
+          <a:solidFill>
+            <a:srgbClr val="F8F1E4"/>
+          </a:solidFill>
+          <a:ln>
+            <a:noFill/>
+          </a:ln>
+        </p:spPr>
+        <p:style>
+          <a:lnRef idx="1">
+            <a:schemeClr val="accent1"/>
+          </a:lnRef>
+          <a:fillRef idx="3">
+            <a:schemeClr val="accent1"/>
+          </a:fillRef>
+          <a:effectRef idx="2">
+            <a:schemeClr val="accent1"/>
+          </a:effectRef>
+          <a:fontRef idx="minor">
+            <a:schemeClr val="lt1"/>
+          </a:fontRef>
+        </p:style>
+        <p:txBody>
+          <a:bodyPr rtlCol="0" anchor="ctr"/>
+          <a:lstStyle/>
+          <a:p>
+            <a:pPr algn="ctr"/>
+          </a:p>
+        </p:txBody>
+      </p:sp>
+      <p:sp>
+        <p:nvSpPr>
+          <p:cNvPr id="32" name="TextBox 31"/>
+          <p:cNvSpPr txBox="1"/>
+          <p:nvPr/>
+        </p:nvSpPr>
+        <p:spPr>
+          <a:xfrm>
+            <a:off x="4100169" y="2121408"/>
+            <a:ext cx="486460" cy="329184"/>
+          </a:xfrm>
+          <a:prstGeom prst="rect">
+            <a:avLst/>
+          </a:prstGeom>
+          <a:noFill/>
+        </p:spPr>
+        <p:txBody>
+          <a:bodyPr wrap="square" lIns="0" rIns="0" tIns="0" bIns="0" anchor="ctr"/>
+          <a:lstStyle/>
+          <a:p>
+            <a:pPr algn="ctr">
+              <a:spcBef>
+                <a:spcPts val="0"/>
+              </a:spcBef>
+              <a:spcAft>
+                <a:spcPts val="0"/>
+              </a:spcAft>
+            </a:pPr>
+            <a:r>
+              <a:rPr sz="1100" b="1">
+                <a:solidFill>
+                  <a:srgbClr val="7A541C"/>
+                </a:solidFill>
+                <a:latin typeface="Microsoft YaHei"/>
+                <a:ea typeface="Microsoft YaHei"/>
+                <a:cs typeface="Microsoft YaHei"/>
+              </a:rPr>
+              <a:t>卡3</a:t>
+            </a:r>
+          </a:p>
+        </p:txBody>
+      </p:sp>
+      <p:sp>
+        <p:nvSpPr>
+          <p:cNvPr id="33" name="Rounded Rectangle 32"/>
+          <p:cNvSpPr/>
+          <p:nvPr/>
+        </p:nvSpPr>
+        <p:spPr>
+          <a:xfrm>
+            <a:off x="4641494" y="2121408"/>
+            <a:ext cx="486460" cy="329184"/>
+          </a:xfrm>
+          <a:prstGeom prst="roundRect">
+            <a:avLst/>
+          </a:prstGeom>
+          <a:solidFill>
+            <a:srgbClr val="F8F1E4"/>
+          </a:solidFill>
+          <a:ln>
+            <a:noFill/>
+          </a:ln>
+        </p:spPr>
+        <p:style>
+          <a:lnRef idx="1">
+            <a:schemeClr val="accent1"/>
+          </a:lnRef>
+          <a:fillRef idx="3">
+            <a:schemeClr val="accent1"/>
+          </a:fillRef>
+          <a:effectRef idx="2">
+            <a:schemeClr val="accent1"/>
+          </a:effectRef>
+          <a:fontRef idx="minor">
+            <a:schemeClr val="lt1"/>
+          </a:fontRef>
+        </p:style>
+        <p:txBody>
+          <a:bodyPr rtlCol="0" anchor="ctr"/>
+          <a:lstStyle/>
+          <a:p>
+            <a:pPr algn="ctr"/>
+          </a:p>
+        </p:txBody>
+      </p:sp>
+      <p:sp>
+        <p:nvSpPr>
+          <p:cNvPr id="34" name="TextBox 33"/>
+          <p:cNvSpPr txBox="1"/>
+          <p:nvPr/>
+        </p:nvSpPr>
+        <p:spPr>
+          <a:xfrm>
+            <a:off x="4641494" y="2121408"/>
+            <a:ext cx="486460" cy="329184"/>
+          </a:xfrm>
+          <a:prstGeom prst="rect">
+            <a:avLst/>
+          </a:prstGeom>
+          <a:noFill/>
+        </p:spPr>
+        <p:txBody>
+          <a:bodyPr wrap="square" lIns="0" rIns="0" tIns="0" bIns="0" anchor="ctr"/>
+          <a:lstStyle/>
+          <a:p>
+            <a:pPr algn="ctr">
+              <a:spcBef>
+                <a:spcPts val="0"/>
+              </a:spcBef>
+              <a:spcAft>
+                <a:spcPts val="0"/>
+              </a:spcAft>
+            </a:pPr>
+            <a:r>
+              <a:rPr sz="1100" b="1">
+                <a:solidFill>
+                  <a:srgbClr val="7A541C"/>
+                </a:solidFill>
+                <a:latin typeface="Microsoft YaHei"/>
+                <a:ea typeface="Microsoft YaHei"/>
+                <a:cs typeface="Microsoft YaHei"/>
+              </a:rPr>
+              <a:t>…</a:t>
+            </a:r>
+          </a:p>
+        </p:txBody>
+      </p:sp>
+      <p:sp>
+        <p:nvSpPr>
+          <p:cNvPr id="35" name="Rounded Rectangle 34"/>
+          <p:cNvSpPr/>
+          <p:nvPr/>
+        </p:nvSpPr>
+        <p:spPr>
+          <a:xfrm>
+            <a:off x="5182819" y="2121408"/>
+            <a:ext cx="486460" cy="329184"/>
+          </a:xfrm>
+          <a:prstGeom prst="roundRect">
+            <a:avLst/>
+          </a:prstGeom>
+          <a:solidFill>
+            <a:srgbClr val="F8F1E4"/>
+          </a:solidFill>
+          <a:ln>
+            <a:noFill/>
+          </a:ln>
+        </p:spPr>
+        <p:style>
+          <a:lnRef idx="1">
+            <a:schemeClr val="accent1"/>
+          </a:lnRef>
+          <a:fillRef idx="3">
+            <a:schemeClr val="accent1"/>
+          </a:fillRef>
+          <a:effectRef idx="2">
+            <a:schemeClr val="accent1"/>
+          </a:effectRef>
+          <a:fontRef idx="minor">
+            <a:schemeClr val="lt1"/>
+          </a:fontRef>
+        </p:style>
+        <p:txBody>
+          <a:bodyPr rtlCol="0" anchor="ctr"/>
+          <a:lstStyle/>
+          <a:p>
+            <a:pPr algn="ctr"/>
+          </a:p>
+        </p:txBody>
+      </p:sp>
+      <p:sp>
+        <p:nvSpPr>
+          <p:cNvPr id="36" name="TextBox 35"/>
+          <p:cNvSpPr txBox="1"/>
+          <p:nvPr/>
+        </p:nvSpPr>
+        <p:spPr>
+          <a:xfrm>
+            <a:off x="5182819" y="2121408"/>
+            <a:ext cx="486460" cy="329184"/>
+          </a:xfrm>
+          <a:prstGeom prst="rect">
+            <a:avLst/>
+          </a:prstGeom>
+          <a:noFill/>
+        </p:spPr>
+        <p:txBody>
+          <a:bodyPr wrap="square" lIns="0" rIns="0" tIns="0" bIns="0" anchor="ctr"/>
+          <a:lstStyle/>
+          <a:p>
+            <a:pPr algn="ctr">
+              <a:spcBef>
+                <a:spcPts val="0"/>
+              </a:spcBef>
+              <a:spcAft>
+                <a:spcPts val="0"/>
+              </a:spcAft>
+            </a:pPr>
+            <a:r>
+              <a:rPr sz="1100" b="1">
+                <a:solidFill>
+                  <a:srgbClr val="7A541C"/>
+                </a:solidFill>
+                <a:latin typeface="Microsoft YaHei"/>
+                <a:ea typeface="Microsoft YaHei"/>
+                <a:cs typeface="Microsoft YaHei"/>
+              </a:rPr>
+              <a:t>卡N</a:t>
+            </a:r>
+          </a:p>
+        </p:txBody>
+      </p:sp>
+      <p:sp>
+        <p:nvSpPr>
+          <p:cNvPr id="37" name="TextBox 36"/>
+          <p:cNvSpPr txBox="1"/>
+          <p:nvPr/>
+        </p:nvSpPr>
+        <p:spPr>
+          <a:xfrm>
+            <a:off x="2999232" y="2505456"/>
+            <a:ext cx="2688336" cy="475488"/>
+          </a:xfrm>
+          <a:prstGeom prst="rect">
+            <a:avLst/>
+          </a:prstGeom>
+          <a:noFill/>
+        </p:spPr>
+        <p:txBody>
+          <a:bodyPr wrap="square" lIns="0" rIns="0" tIns="0" bIns="0" anchor="ctr"/>
           <a:lstStyle/>
           <a:p>
             <a:pPr algn="ctr">
@@ -4056,27 +5039,111 @@
                 <a:ea typeface="Microsoft YaHei"/>
                 <a:cs typeface="Microsoft YaHei"/>
               </a:rPr>
-              <a:t>要换入或换出一块 KV</a:t>
-            </a:r>
-          </a:p>
-        </p:txBody>
-      </p:sp>
-      <p:sp>
-        <p:nvSpPr>
-          <p:cNvPr id="15" name="Down Arrow 14"/>
+              <a:t>入队：块 id、字节数、换入或换出</a:t>
+            </a:r>
+          </a:p>
+          <a:p>
+            <a:pPr algn="ctr">
+              <a:spcBef>
+                <a:spcPts val="0"/>
+              </a:spcBef>
+              <a:spcAft>
+                <a:spcPts val="0"/>
+              </a:spcAft>
+            </a:pPr>
+            <a:r>
+              <a:rPr sz="1200" b="0">
+                <a:solidFill>
+                  <a:srgbClr val="1C242E"/>
+                </a:solidFill>
+                <a:latin typeface="Microsoft YaHei"/>
+                <a:ea typeface="Microsoft YaHei"/>
+                <a:cs typeface="Microsoft YaHei"/>
+              </a:rPr>
+              <a:t>出队：池内偏移、长度、租约</a:t>
+            </a:r>
+          </a:p>
+        </p:txBody>
+      </p:sp>
+      <p:sp>
+        <p:nvSpPr>
+          <p:cNvPr id="38" name="TextBox 37"/>
+          <p:cNvSpPr txBox="1"/>
+          <p:nvPr/>
+        </p:nvSpPr>
+        <p:spPr>
+          <a:xfrm>
+            <a:off x="2999232" y="2999232"/>
+            <a:ext cx="2688336" cy="475488"/>
+          </a:xfrm>
+          <a:prstGeom prst="rect">
+            <a:avLst/>
+          </a:prstGeom>
+          <a:noFill/>
+        </p:spPr>
+        <p:txBody>
+          <a:bodyPr wrap="square" lIns="0" rIns="0" tIns="0" bIns="0" anchor="ctr"/>
+          <a:lstStyle/>
+          <a:p>
+            <a:pPr algn="ctr">
+              <a:spcBef>
+                <a:spcPts val="0"/>
+              </a:spcBef>
+              <a:spcAft>
+                <a:spcPts val="0"/>
+              </a:spcAft>
+            </a:pPr>
+            <a:r>
+              <a:rPr sz="1200" b="0">
+                <a:solidFill>
+                  <a:srgbClr val="7A541C"/>
+                </a:solidFill>
+                <a:latin typeface="Microsoft YaHei"/>
+                <a:ea typeface="Microsoft YaHei"/>
+                <a:cs typeface="Microsoft YaHei"/>
+              </a:rPr>
+              <a:t>多卡同时 swap，队列变长</a:t>
+            </a:r>
+          </a:p>
+          <a:p>
+            <a:pPr algn="ctr">
+              <a:spcBef>
+                <a:spcPts val="0"/>
+              </a:spcBef>
+              <a:spcAft>
+                <a:spcPts val="0"/>
+              </a:spcAft>
+            </a:pPr>
+            <a:r>
+              <a:rPr sz="1200" b="0">
+                <a:solidFill>
+                  <a:srgbClr val="7A541C"/>
+                </a:solidFill>
+                <a:latin typeface="Microsoft YaHei"/>
+                <a:ea typeface="Microsoft YaHei"/>
+                <a:cs typeface="Microsoft YaHei"/>
+              </a:rPr>
+              <a:t>DMA 约 0.06 ms，往返按 0.2 ms</a:t>
+            </a:r>
+          </a:p>
+        </p:txBody>
+      </p:sp>
+      <p:sp>
+        <p:nvSpPr>
+          <p:cNvPr id="39" name="Down Arrow 38"/>
           <p:cNvSpPr/>
           <p:nvPr/>
         </p:nvSpPr>
         <p:spPr>
           <a:xfrm>
-            <a:off x="1440180" y="2395728"/>
-            <a:ext cx="201168" cy="256032"/>
+            <a:off x="2926080" y="3694176"/>
+            <a:ext cx="256032" cy="256032"/>
           </a:xfrm>
           <a:prstGeom prst="downArrow">
             <a:avLst/>
           </a:prstGeom>
           <a:solidFill>
-            <a:srgbClr val="0E2A47"/>
+            <a:srgbClr val="0E7A76"/>
           </a:solidFill>
           <a:ln>
             <a:noFill/>
@@ -4106,14 +5173,14 @@
       </p:sp>
       <p:sp>
         <p:nvSpPr>
-          <p:cNvPr id="16" name="TextBox 15"/>
+          <p:cNvPr id="40" name="TextBox 39"/>
           <p:cNvSpPr txBox="1"/>
           <p:nvPr/>
         </p:nvSpPr>
         <p:spPr>
           <a:xfrm>
-            <a:off x="1714500" y="2322576"/>
-            <a:ext cx="3246120" cy="402336"/>
+            <a:off x="3218688" y="3657600"/>
+            <a:ext cx="2468880" cy="329184"/>
           </a:xfrm>
           <a:prstGeom prst="rect">
             <a:avLst/>
@@ -4133,29 +5200,780 @@
               </a:spcAft>
             </a:pPr>
             <a:r>
-              <a:rPr sz="1300" b="1">
+              <a:rPr sz="1200" b="1">
                 <a:solidFill>
-                  <a:srgbClr val="0E2A47"/>
+                  <a:srgbClr val="0E7A76"/>
                 </a:solidFill>
                 <a:latin typeface="Microsoft YaHei"/>
                 <a:ea typeface="Microsoft YaHei"/>
                 <a:cs typeface="Microsoft YaHei"/>
               </a:rPr>
-              <a:t>块 id，字节数，换入或换出</a:t>
-            </a:r>
-          </a:p>
-        </p:txBody>
-      </p:sp>
-      <p:sp>
-        <p:nvSpPr>
-          <p:cNvPr id="17" name="Rounded Rectangle 16"/>
+              <a:t>出队后才走总线平面</a:t>
+            </a:r>
+          </a:p>
+        </p:txBody>
+      </p:sp>
+      <p:sp>
+        <p:nvSpPr>
+          <p:cNvPr id="41" name="Rounded Rectangle 40"/>
           <p:cNvSpPr/>
           <p:nvPr/>
         </p:nvSpPr>
         <p:spPr>
           <a:xfrm>
-            <a:off x="530352" y="2743200"/>
-            <a:ext cx="5340096" cy="658368"/>
+            <a:off x="475488" y="4023360"/>
+            <a:ext cx="5321808" cy="713232"/>
+          </a:xfrm>
+          <a:prstGeom prst="roundRect">
+            <a:avLst/>
+          </a:prstGeom>
+          <a:solidFill>
+            <a:srgbClr val="E7F3F2"/>
+          </a:solidFill>
+          <a:ln w="12700">
+            <a:solidFill>
+              <a:srgbClr val="0E7A76"/>
+            </a:solidFill>
+          </a:ln>
+        </p:spPr>
+        <p:style>
+          <a:lnRef idx="1">
+            <a:schemeClr val="accent1"/>
+          </a:lnRef>
+          <a:fillRef idx="3">
+            <a:schemeClr val="accent1"/>
+          </a:fillRef>
+          <a:effectRef idx="2">
+            <a:schemeClr val="accent1"/>
+          </a:effectRef>
+          <a:fontRef idx="minor">
+            <a:schemeClr val="lt1"/>
+          </a:fontRef>
+        </p:style>
+        <p:txBody>
+          <a:bodyPr rtlCol="0" anchor="ctr"/>
+          <a:lstStyle/>
+          <a:p>
+            <a:pPr algn="ctr"/>
+          </a:p>
+        </p:txBody>
+      </p:sp>
+      <p:sp>
+        <p:nvSpPr>
+          <p:cNvPr id="42" name="TextBox 41"/>
+          <p:cNvSpPr txBox="1"/>
+          <p:nvPr/>
+        </p:nvSpPr>
+        <p:spPr>
+          <a:xfrm>
+            <a:off x="603504" y="4078224"/>
+            <a:ext cx="2103120" cy="274320"/>
+          </a:xfrm>
+          <a:prstGeom prst="rect">
+            <a:avLst/>
+          </a:prstGeom>
+          <a:noFill/>
+        </p:spPr>
+        <p:txBody>
+          <a:bodyPr wrap="square" lIns="0" rIns="0" tIns="0" bIns="0" anchor="ctr"/>
+          <a:lstStyle/>
+          <a:p>
+            <a:pPr algn="l">
+              <a:spcBef>
+                <a:spcPts val="0"/>
+              </a:spcBef>
+              <a:spcAft>
+                <a:spcPts val="0"/>
+              </a:spcAft>
+            </a:pPr>
+            <a:r>
+              <a:rPr sz="1400" b="1">
+                <a:solidFill>
+                  <a:srgbClr val="0E7A76"/>
+                </a:solidFill>
+                <a:latin typeface="Microsoft YaHei"/>
+                <a:ea typeface="Microsoft YaHei"/>
+                <a:cs typeface="Microsoft YaHei"/>
+              </a:rPr>
+              <a:t>DDR 池</a:t>
+            </a:r>
+          </a:p>
+        </p:txBody>
+      </p:sp>
+      <p:sp>
+        <p:nvSpPr>
+          <p:cNvPr id="43" name="TextBox 42"/>
+          <p:cNvSpPr txBox="1"/>
+          <p:nvPr/>
+        </p:nvSpPr>
+        <p:spPr>
+          <a:xfrm>
+            <a:off x="603504" y="4352544"/>
+            <a:ext cx="5029200" cy="292608"/>
+          </a:xfrm>
+          <a:prstGeom prst="rect">
+            <a:avLst/>
+          </a:prstGeom>
+          <a:noFill/>
+        </p:spPr>
+        <p:txBody>
+          <a:bodyPr wrap="square" lIns="0" rIns="0" tIns="0" bIns="0" anchor="ctr"/>
+          <a:lstStyle/>
+          <a:p>
+            <a:pPr algn="l">
+              <a:spcBef>
+                <a:spcPts val="0"/>
+              </a:spcBef>
+              <a:spcAft>
+                <a:spcPts val="0"/>
+              </a:spcAft>
+            </a:pPr>
+            <a:r>
+              <a:rPr sz="1200" b="0">
+                <a:solidFill>
+                  <a:srgbClr val="1C242E"/>
+                </a:solidFill>
+                <a:latin typeface="Microsoft YaHei"/>
+                <a:ea typeface="Microsoft YaHei"/>
+                <a:cs typeface="Microsoft YaHei"/>
+              </a:rPr>
+              <a:t>直挂总线。KV 按偏移 DMA 进来，字节不进 Master。</a:t>
+            </a:r>
+          </a:p>
+        </p:txBody>
+      </p:sp>
+      <p:sp>
+        <p:nvSpPr>
+          <p:cNvPr id="44" name="Rounded Rectangle 43"/>
+          <p:cNvSpPr/>
+          <p:nvPr/>
+        </p:nvSpPr>
+        <p:spPr>
+          <a:xfrm>
+            <a:off x="6400800" y="1572768"/>
+            <a:ext cx="1700784" cy="621792"/>
+          </a:xfrm>
+          <a:prstGeom prst="roundRect">
+            <a:avLst/>
+          </a:prstGeom>
+          <a:solidFill>
+            <a:srgbClr val="E7F3F2"/>
+          </a:solidFill>
+          <a:ln w="12700">
+            <a:solidFill>
+              <a:srgbClr val="D6DCE2"/>
+            </a:solidFill>
+          </a:ln>
+        </p:spPr>
+        <p:style>
+          <a:lnRef idx="1">
+            <a:schemeClr val="accent1"/>
+          </a:lnRef>
+          <a:fillRef idx="3">
+            <a:schemeClr val="accent1"/>
+          </a:fillRef>
+          <a:effectRef idx="2">
+            <a:schemeClr val="accent1"/>
+          </a:effectRef>
+          <a:fontRef idx="minor">
+            <a:schemeClr val="lt1"/>
+          </a:fontRef>
+        </p:style>
+        <p:txBody>
+          <a:bodyPr rtlCol="0" anchor="ctr"/>
+          <a:lstStyle/>
+          <a:p>
+            <a:pPr algn="ctr"/>
+          </a:p>
+        </p:txBody>
+      </p:sp>
+      <p:sp>
+        <p:nvSpPr>
+          <p:cNvPr id="45" name="TextBox 44"/>
+          <p:cNvSpPr txBox="1"/>
+          <p:nvPr/>
+        </p:nvSpPr>
+        <p:spPr>
+          <a:xfrm>
+            <a:off x="6455664" y="1609344"/>
+            <a:ext cx="1591056" cy="256032"/>
+          </a:xfrm>
+          <a:prstGeom prst="rect">
+            <a:avLst/>
+          </a:prstGeom>
+          <a:noFill/>
+        </p:spPr>
+        <p:txBody>
+          <a:bodyPr wrap="square" lIns="0" rIns="0" tIns="0" bIns="0" anchor="ctr"/>
+          <a:lstStyle/>
+          <a:p>
+            <a:pPr algn="ctr">
+              <a:spcBef>
+                <a:spcPts val="0"/>
+              </a:spcBef>
+              <a:spcAft>
+                <a:spcPts val="0"/>
+              </a:spcAft>
+            </a:pPr>
+            <a:r>
+              <a:rPr sz="1200" b="1">
+                <a:solidFill>
+                  <a:srgbClr val="0E7A76"/>
+                </a:solidFill>
+                <a:latin typeface="Microsoft YaHei"/>
+                <a:ea typeface="Microsoft YaHei"/>
+                <a:cs typeface="Microsoft YaHei"/>
+              </a:rPr>
+              <a:t>Decode 卡 1</a:t>
+            </a:r>
+          </a:p>
+        </p:txBody>
+      </p:sp>
+      <p:sp>
+        <p:nvSpPr>
+          <p:cNvPr id="46" name="TextBox 45"/>
+          <p:cNvSpPr txBox="1"/>
+          <p:nvPr/>
+        </p:nvSpPr>
+        <p:spPr>
+          <a:xfrm>
+            <a:off x="6455664" y="1847088"/>
+            <a:ext cx="1591056" cy="292608"/>
+          </a:xfrm>
+          <a:prstGeom prst="rect">
+            <a:avLst/>
+          </a:prstGeom>
+          <a:noFill/>
+        </p:spPr>
+        <p:txBody>
+          <a:bodyPr wrap="square" lIns="0" rIns="0" tIns="0" bIns="0" anchor="ctr"/>
+          <a:lstStyle/>
+          <a:p>
+            <a:pPr algn="ctr">
+              <a:spcBef>
+                <a:spcPts val="0"/>
+              </a:spcBef>
+              <a:spcAft>
+                <a:spcPts val="0"/>
+              </a:spcAft>
+            </a:pPr>
+            <a:r>
+              <a:rPr sz="1100" b="0">
+                <a:solidFill>
+                  <a:srgbClr val="5A636E"/>
+                </a:solidFill>
+                <a:latin typeface="Microsoft YaHei"/>
+                <a:ea typeface="Microsoft YaHei"/>
+                <a:cs typeface="Microsoft YaHei"/>
+              </a:rPr>
+              <a:t>块表里已有偏移</a:t>
+            </a:r>
+          </a:p>
+        </p:txBody>
+      </p:sp>
+      <p:sp>
+        <p:nvSpPr>
+          <p:cNvPr id="47" name="Rounded Rectangle 46"/>
+          <p:cNvSpPr/>
+          <p:nvPr/>
+        </p:nvSpPr>
+        <p:spPr>
+          <a:xfrm>
+            <a:off x="8193024" y="1572768"/>
+            <a:ext cx="1700784" cy="621792"/>
+          </a:xfrm>
+          <a:prstGeom prst="roundRect">
+            <a:avLst/>
+          </a:prstGeom>
+          <a:solidFill>
+            <a:srgbClr val="E7F3F2"/>
+          </a:solidFill>
+          <a:ln w="12700">
+            <a:solidFill>
+              <a:srgbClr val="D6DCE2"/>
+            </a:solidFill>
+          </a:ln>
+        </p:spPr>
+        <p:style>
+          <a:lnRef idx="1">
+            <a:schemeClr val="accent1"/>
+          </a:lnRef>
+          <a:fillRef idx="3">
+            <a:schemeClr val="accent1"/>
+          </a:fillRef>
+          <a:effectRef idx="2">
+            <a:schemeClr val="accent1"/>
+          </a:effectRef>
+          <a:fontRef idx="minor">
+            <a:schemeClr val="lt1"/>
+          </a:fontRef>
+        </p:style>
+        <p:txBody>
+          <a:bodyPr rtlCol="0" anchor="ctr"/>
+          <a:lstStyle/>
+          <a:p>
+            <a:pPr algn="ctr"/>
+          </a:p>
+        </p:txBody>
+      </p:sp>
+      <p:sp>
+        <p:nvSpPr>
+          <p:cNvPr id="48" name="TextBox 47"/>
+          <p:cNvSpPr txBox="1"/>
+          <p:nvPr/>
+        </p:nvSpPr>
+        <p:spPr>
+          <a:xfrm>
+            <a:off x="8247888" y="1609344"/>
+            <a:ext cx="1591056" cy="256032"/>
+          </a:xfrm>
+          <a:prstGeom prst="rect">
+            <a:avLst/>
+          </a:prstGeom>
+          <a:noFill/>
+        </p:spPr>
+        <p:txBody>
+          <a:bodyPr wrap="square" lIns="0" rIns="0" tIns="0" bIns="0" anchor="ctr"/>
+          <a:lstStyle/>
+          <a:p>
+            <a:pPr algn="ctr">
+              <a:spcBef>
+                <a:spcPts val="0"/>
+              </a:spcBef>
+              <a:spcAft>
+                <a:spcPts val="0"/>
+              </a:spcAft>
+            </a:pPr>
+            <a:r>
+              <a:rPr sz="1200" b="1">
+                <a:solidFill>
+                  <a:srgbClr val="0E7A76"/>
+                </a:solidFill>
+                <a:latin typeface="Microsoft YaHei"/>
+                <a:ea typeface="Microsoft YaHei"/>
+                <a:cs typeface="Microsoft YaHei"/>
+              </a:rPr>
+              <a:t>Decode 卡 2</a:t>
+            </a:r>
+          </a:p>
+        </p:txBody>
+      </p:sp>
+      <p:sp>
+        <p:nvSpPr>
+          <p:cNvPr id="49" name="TextBox 48"/>
+          <p:cNvSpPr txBox="1"/>
+          <p:nvPr/>
+        </p:nvSpPr>
+        <p:spPr>
+          <a:xfrm>
+            <a:off x="8247888" y="1847088"/>
+            <a:ext cx="1591056" cy="292608"/>
+          </a:xfrm>
+          <a:prstGeom prst="rect">
+            <a:avLst/>
+          </a:prstGeom>
+          <a:noFill/>
+        </p:spPr>
+        <p:txBody>
+          <a:bodyPr wrap="square" lIns="0" rIns="0" tIns="0" bIns="0" anchor="ctr"/>
+          <a:lstStyle/>
+          <a:p>
+            <a:pPr algn="ctr">
+              <a:spcBef>
+                <a:spcPts val="0"/>
+              </a:spcBef>
+              <a:spcAft>
+                <a:spcPts val="0"/>
+              </a:spcAft>
+            </a:pPr>
+            <a:r>
+              <a:rPr sz="1100" b="0">
+                <a:solidFill>
+                  <a:srgbClr val="5A636E"/>
+                </a:solidFill>
+                <a:latin typeface="Microsoft YaHei"/>
+                <a:ea typeface="Microsoft YaHei"/>
+                <a:cs typeface="Microsoft YaHei"/>
+              </a:rPr>
+              <a:t>块表里已有偏移</a:t>
+            </a:r>
+          </a:p>
+        </p:txBody>
+      </p:sp>
+      <p:sp>
+        <p:nvSpPr>
+          <p:cNvPr id="50" name="Rounded Rectangle 49"/>
+          <p:cNvSpPr/>
+          <p:nvPr/>
+        </p:nvSpPr>
+        <p:spPr>
+          <a:xfrm>
+            <a:off x="9985248" y="1572768"/>
+            <a:ext cx="1700784" cy="621792"/>
+          </a:xfrm>
+          <a:prstGeom prst="roundRect">
+            <a:avLst/>
+          </a:prstGeom>
+          <a:solidFill>
+            <a:srgbClr val="E7F3F2"/>
+          </a:solidFill>
+          <a:ln w="12700">
+            <a:solidFill>
+              <a:srgbClr val="D6DCE2"/>
+            </a:solidFill>
+          </a:ln>
+        </p:spPr>
+        <p:style>
+          <a:lnRef idx="1">
+            <a:schemeClr val="accent1"/>
+          </a:lnRef>
+          <a:fillRef idx="3">
+            <a:schemeClr val="accent1"/>
+          </a:fillRef>
+          <a:effectRef idx="2">
+            <a:schemeClr val="accent1"/>
+          </a:effectRef>
+          <a:fontRef idx="minor">
+            <a:schemeClr val="lt1"/>
+          </a:fontRef>
+        </p:style>
+        <p:txBody>
+          <a:bodyPr rtlCol="0" anchor="ctr"/>
+          <a:lstStyle/>
+          <a:p>
+            <a:pPr algn="ctr"/>
+          </a:p>
+        </p:txBody>
+      </p:sp>
+      <p:sp>
+        <p:nvSpPr>
+          <p:cNvPr id="51" name="TextBox 50"/>
+          <p:cNvSpPr txBox="1"/>
+          <p:nvPr/>
+        </p:nvSpPr>
+        <p:spPr>
+          <a:xfrm>
+            <a:off x="10040112" y="1609344"/>
+            <a:ext cx="1591056" cy="256032"/>
+          </a:xfrm>
+          <a:prstGeom prst="rect">
+            <a:avLst/>
+          </a:prstGeom>
+          <a:noFill/>
+        </p:spPr>
+        <p:txBody>
+          <a:bodyPr wrap="square" lIns="0" rIns="0" tIns="0" bIns="0" anchor="ctr"/>
+          <a:lstStyle/>
+          <a:p>
+            <a:pPr algn="ctr">
+              <a:spcBef>
+                <a:spcPts val="0"/>
+              </a:spcBef>
+              <a:spcAft>
+                <a:spcPts val="0"/>
+              </a:spcAft>
+            </a:pPr>
+            <a:r>
+              <a:rPr sz="1200" b="1">
+                <a:solidFill>
+                  <a:srgbClr val="0E7A76"/>
+                </a:solidFill>
+                <a:latin typeface="Microsoft YaHei"/>
+                <a:ea typeface="Microsoft YaHei"/>
+                <a:cs typeface="Microsoft YaHei"/>
+              </a:rPr>
+              <a:t>Decode 卡 N</a:t>
+            </a:r>
+          </a:p>
+        </p:txBody>
+      </p:sp>
+      <p:sp>
+        <p:nvSpPr>
+          <p:cNvPr id="52" name="TextBox 51"/>
+          <p:cNvSpPr txBox="1"/>
+          <p:nvPr/>
+        </p:nvSpPr>
+        <p:spPr>
+          <a:xfrm>
+            <a:off x="10040112" y="1847088"/>
+            <a:ext cx="1591056" cy="292608"/>
+          </a:xfrm>
+          <a:prstGeom prst="rect">
+            <a:avLst/>
+          </a:prstGeom>
+          <a:noFill/>
+        </p:spPr>
+        <p:txBody>
+          <a:bodyPr wrap="square" lIns="0" rIns="0" tIns="0" bIns="0" anchor="ctr"/>
+          <a:lstStyle/>
+          <a:p>
+            <a:pPr algn="ctr">
+              <a:spcBef>
+                <a:spcPts val="0"/>
+              </a:spcBef>
+              <a:spcAft>
+                <a:spcPts val="0"/>
+              </a:spcAft>
+            </a:pPr>
+            <a:r>
+              <a:rPr sz="1100" b="0">
+                <a:solidFill>
+                  <a:srgbClr val="5A636E"/>
+                </a:solidFill>
+                <a:latin typeface="Microsoft YaHei"/>
+                <a:ea typeface="Microsoft YaHei"/>
+                <a:cs typeface="Microsoft YaHei"/>
+              </a:rPr>
+              <a:t>块表里已有偏移</a:t>
+            </a:r>
+          </a:p>
+        </p:txBody>
+      </p:sp>
+      <p:sp>
+        <p:nvSpPr>
+          <p:cNvPr id="53" name="Down Arrow 52"/>
+          <p:cNvSpPr/>
+          <p:nvPr/>
+        </p:nvSpPr>
+        <p:spPr>
+          <a:xfrm>
+            <a:off x="8851392" y="2267712"/>
+            <a:ext cx="256032" cy="237744"/>
+          </a:xfrm>
+          <a:prstGeom prst="downArrow">
+            <a:avLst/>
+          </a:prstGeom>
+          <a:solidFill>
+            <a:srgbClr val="0E7A76"/>
+          </a:solidFill>
+          <a:ln>
+            <a:noFill/>
+          </a:ln>
+        </p:spPr>
+        <p:style>
+          <a:lnRef idx="1">
+            <a:schemeClr val="accent1"/>
+          </a:lnRef>
+          <a:fillRef idx="3">
+            <a:schemeClr val="accent1"/>
+          </a:fillRef>
+          <a:effectRef idx="2">
+            <a:schemeClr val="accent1"/>
+          </a:effectRef>
+          <a:fontRef idx="minor">
+            <a:schemeClr val="lt1"/>
+          </a:fontRef>
+        </p:style>
+        <p:txBody>
+          <a:bodyPr rtlCol="0" anchor="ctr"/>
+          <a:lstStyle/>
+          <a:p>
+            <a:pPr algn="ctr"/>
+          </a:p>
+        </p:txBody>
+      </p:sp>
+      <p:sp>
+        <p:nvSpPr>
+          <p:cNvPr id="54" name="TextBox 53"/>
+          <p:cNvSpPr txBox="1"/>
+          <p:nvPr/>
+        </p:nvSpPr>
+        <p:spPr>
+          <a:xfrm>
+            <a:off x="9162288" y="2231136"/>
+            <a:ext cx="2286000" cy="292608"/>
+          </a:xfrm>
+          <a:prstGeom prst="rect">
+            <a:avLst/>
+          </a:prstGeom>
+          <a:noFill/>
+        </p:spPr>
+        <p:txBody>
+          <a:bodyPr wrap="square" lIns="0" rIns="0" tIns="0" bIns="0" anchor="ctr"/>
+          <a:lstStyle/>
+          <a:p>
+            <a:pPr algn="l">
+              <a:spcBef>
+                <a:spcPts val="0"/>
+              </a:spcBef>
+              <a:spcAft>
+                <a:spcPts val="0"/>
+              </a:spcAft>
+            </a:pPr>
+            <a:r>
+              <a:rPr sz="1200" b="1">
+                <a:solidFill>
+                  <a:srgbClr val="0E7A76"/>
+                </a:solidFill>
+                <a:latin typeface="Microsoft YaHei"/>
+                <a:ea typeface="Microsoft YaHei"/>
+                <a:cs typeface="Microsoft YaHei"/>
+              </a:rPr>
+              <a:t>总线平面</a:t>
+            </a:r>
+          </a:p>
+        </p:txBody>
+      </p:sp>
+      <p:sp>
+        <p:nvSpPr>
+          <p:cNvPr id="55" name="Rounded Rectangle 54"/>
+          <p:cNvSpPr/>
+          <p:nvPr/>
+        </p:nvSpPr>
+        <p:spPr>
+          <a:xfrm>
+            <a:off x="6400800" y="2578608"/>
+            <a:ext cx="5303520" cy="960120"/>
+          </a:xfrm>
+          <a:prstGeom prst="roundRect">
+            <a:avLst/>
+          </a:prstGeom>
+          <a:solidFill>
+            <a:srgbClr val="E7F3F2"/>
+          </a:solidFill>
+          <a:ln w="12700">
+            <a:solidFill>
+              <a:srgbClr val="0E7A76"/>
+            </a:solidFill>
+          </a:ln>
+        </p:spPr>
+        <p:style>
+          <a:lnRef idx="1">
+            <a:schemeClr val="accent1"/>
+          </a:lnRef>
+          <a:fillRef idx="3">
+            <a:schemeClr val="accent1"/>
+          </a:fillRef>
+          <a:effectRef idx="2">
+            <a:schemeClr val="accent1"/>
+          </a:effectRef>
+          <a:fontRef idx="minor">
+            <a:schemeClr val="lt1"/>
+          </a:fontRef>
+        </p:style>
+        <p:txBody>
+          <a:bodyPr rtlCol="0" anchor="ctr"/>
+          <a:lstStyle/>
+          <a:p>
+            <a:pPr algn="ctr"/>
+          </a:p>
+        </p:txBody>
+      </p:sp>
+      <p:sp>
+        <p:nvSpPr>
+          <p:cNvPr id="56" name="TextBox 55"/>
+          <p:cNvSpPr txBox="1"/>
+          <p:nvPr/>
+        </p:nvSpPr>
+        <p:spPr>
+          <a:xfrm>
+            <a:off x="6547104" y="2670048"/>
+            <a:ext cx="5010912" cy="292608"/>
+          </a:xfrm>
+          <a:prstGeom prst="rect">
+            <a:avLst/>
+          </a:prstGeom>
+          <a:noFill/>
+        </p:spPr>
+        <p:txBody>
+          <a:bodyPr wrap="square" lIns="0" rIns="0" tIns="0" bIns="0" anchor="ctr"/>
+          <a:lstStyle/>
+          <a:p>
+            <a:pPr algn="ctr">
+              <a:spcBef>
+                <a:spcPts val="0"/>
+              </a:spcBef>
+              <a:spcAft>
+                <a:spcPts val="0"/>
+              </a:spcAft>
+            </a:pPr>
+            <a:r>
+              <a:rPr sz="1600" b="1">
+                <a:solidFill>
+                  <a:srgbClr val="0E7A76"/>
+                </a:solidFill>
+                <a:latin typeface="Microsoft YaHei"/>
+                <a:ea typeface="Microsoft YaHei"/>
+                <a:cs typeface="Microsoft YaHei"/>
+              </a:rPr>
+              <a:t>DDR 池</a:t>
+            </a:r>
+          </a:p>
+        </p:txBody>
+      </p:sp>
+      <p:sp>
+        <p:nvSpPr>
+          <p:cNvPr id="57" name="TextBox 56"/>
+          <p:cNvSpPr txBox="1"/>
+          <p:nvPr/>
+        </p:nvSpPr>
+        <p:spPr>
+          <a:xfrm>
+            <a:off x="6547104" y="2980944"/>
+            <a:ext cx="5010912" cy="420624"/>
+          </a:xfrm>
+          <a:prstGeom prst="rect">
+            <a:avLst/>
+          </a:prstGeom>
+          <a:noFill/>
+        </p:spPr>
+        <p:txBody>
+          <a:bodyPr wrap="square" lIns="0" rIns="0" tIns="0" bIns="0" anchor="ctr"/>
+          <a:lstStyle/>
+          <a:p>
+            <a:pPr algn="ctr">
+              <a:spcBef>
+                <a:spcPts val="0"/>
+              </a:spcBef>
+              <a:spcAft>
+                <a:spcPts val="0"/>
+              </a:spcAft>
+            </a:pPr>
+            <a:r>
+              <a:rPr sz="1300" b="0">
+                <a:solidFill>
+                  <a:srgbClr val="1C242E"/>
+                </a:solidFill>
+                <a:latin typeface="Microsoft YaHei"/>
+                <a:ea typeface="Microsoft YaHei"/>
+                <a:cs typeface="Microsoft YaHei"/>
+              </a:rPr>
+              <a:t>热路径。三张卡按自己块表里的偏移做 DMA。</a:t>
+            </a:r>
+          </a:p>
+          <a:p>
+            <a:pPr algn="ctr">
+              <a:spcBef>
+                <a:spcPts val="0"/>
+              </a:spcBef>
+              <a:spcAft>
+                <a:spcPts val="0"/>
+              </a:spcAft>
+            </a:pPr>
+            <a:r>
+              <a:rPr sz="1300" b="0">
+                <a:solidFill>
+                  <a:srgbClr val="1C242E"/>
+                </a:solidFill>
+                <a:latin typeface="Microsoft YaHei"/>
+                <a:ea typeface="Microsoft YaHei"/>
+                <a:cs typeface="Microsoft YaHei"/>
+              </a:rPr>
+              <a:t>不等待 Master。</a:t>
+            </a:r>
+          </a:p>
+        </p:txBody>
+      </p:sp>
+      <p:sp>
+        <p:nvSpPr>
+          <p:cNvPr id="58" name="Rounded Rectangle 57"/>
+          <p:cNvSpPr/>
+          <p:nvPr/>
+        </p:nvSpPr>
+        <p:spPr>
+          <a:xfrm>
+            <a:off x="6400800" y="3675887"/>
+            <a:ext cx="5303520" cy="1060704"/>
           </a:xfrm>
           <a:prstGeom prst="roundRect">
             <a:avLst/>
@@ -4193,14 +6011,143 @@
       </p:sp>
       <p:sp>
         <p:nvSpPr>
-          <p:cNvPr id="18" name="TextBox 17"/>
+          <p:cNvPr id="59" name="TextBox 58"/>
           <p:cNvSpPr txBox="1"/>
           <p:nvPr/>
         </p:nvSpPr>
         <p:spPr>
           <a:xfrm>
-            <a:off x="640080" y="2798064"/>
-            <a:ext cx="5120640" cy="292608"/>
+            <a:off x="6528816" y="3730752"/>
+            <a:ext cx="2194560" cy="256032"/>
+          </a:xfrm>
+          <a:prstGeom prst="rect">
+            <a:avLst/>
+          </a:prstGeom>
+          <a:noFill/>
+        </p:spPr>
+        <p:txBody>
+          <a:bodyPr wrap="square" lIns="0" rIns="0" tIns="0" bIns="0" anchor="ctr"/>
+          <a:lstStyle/>
+          <a:p>
+            <a:pPr algn="l">
+              <a:spcBef>
+                <a:spcPts val="0"/>
+              </a:spcBef>
+              <a:spcAft>
+                <a:spcPts val="0"/>
+              </a:spcAft>
+            </a:pPr>
+            <a:r>
+              <a:rPr sz="1400" b="1">
+                <a:solidFill>
+                  <a:srgbClr val="5A636E"/>
+                </a:solidFill>
+                <a:latin typeface="Microsoft YaHei"/>
+                <a:ea typeface="Microsoft YaHei"/>
+                <a:cs typeface="Microsoft YaHei"/>
+              </a:rPr>
+              <a:t>Master 节点</a:t>
+            </a:r>
+          </a:p>
+        </p:txBody>
+      </p:sp>
+      <p:sp>
+        <p:nvSpPr>
+          <p:cNvPr id="60" name="TextBox 59"/>
+          <p:cNvSpPr txBox="1"/>
+          <p:nvPr/>
+        </p:nvSpPr>
+        <p:spPr>
+          <a:xfrm>
+            <a:off x="8686800" y="3730752"/>
+            <a:ext cx="2871216" cy="256032"/>
+          </a:xfrm>
+          <a:prstGeom prst="rect">
+            <a:avLst/>
+          </a:prstGeom>
+          <a:noFill/>
+        </p:spPr>
+        <p:txBody>
+          <a:bodyPr wrap="square" lIns="0" rIns="0" tIns="0" bIns="0" anchor="ctr"/>
+          <a:lstStyle/>
+          <a:p>
+            <a:pPr algn="r">
+              <a:spcBef>
+                <a:spcPts val="0"/>
+              </a:spcBef>
+              <a:spcAft>
+                <a:spcPts val="0"/>
+              </a:spcAft>
+            </a:pPr>
+            <a:r>
+              <a:rPr sz="1200" b="1">
+                <a:solidFill>
+                  <a:srgbClr val="0E7A76"/>
+                </a:solidFill>
+                <a:latin typeface="Microsoft YaHei"/>
+                <a:ea typeface="Microsoft YaHei"/>
+                <a:cs typeface="Microsoft YaHei"/>
+              </a:rPr>
+              <a:t>热路径上没有这条队列</a:t>
+            </a:r>
+          </a:p>
+        </p:txBody>
+      </p:sp>
+      <p:sp>
+        <p:nvSpPr>
+          <p:cNvPr id="61" name="Rounded Rectangle 60"/>
+          <p:cNvSpPr/>
+          <p:nvPr/>
+        </p:nvSpPr>
+        <p:spPr>
+          <a:xfrm>
+            <a:off x="6547104" y="4041648"/>
+            <a:ext cx="740664" cy="329184"/>
+          </a:xfrm>
+          <a:prstGeom prst="roundRect">
+            <a:avLst/>
+          </a:prstGeom>
+          <a:solidFill>
+            <a:srgbClr val="FFFFFF"/>
+          </a:solidFill>
+          <a:ln w="12700">
+            <a:solidFill>
+              <a:srgbClr val="D6DCE2"/>
+            </a:solidFill>
+          </a:ln>
+        </p:spPr>
+        <p:style>
+          <a:lnRef idx="1">
+            <a:schemeClr val="accent1"/>
+          </a:lnRef>
+          <a:fillRef idx="3">
+            <a:schemeClr val="accent1"/>
+          </a:fillRef>
+          <a:effectRef idx="2">
+            <a:schemeClr val="accent1"/>
+          </a:effectRef>
+          <a:fontRef idx="minor">
+            <a:schemeClr val="lt1"/>
+          </a:fontRef>
+        </p:style>
+        <p:txBody>
+          <a:bodyPr rtlCol="0" anchor="ctr"/>
+          <a:lstStyle/>
+          <a:p>
+            <a:pPr algn="ctr"/>
+          </a:p>
+        </p:txBody>
+      </p:sp>
+      <p:sp>
+        <p:nvSpPr>
+          <p:cNvPr id="62" name="TextBox 61"/>
+          <p:cNvSpPr txBox="1"/>
+          <p:nvPr/>
+        </p:nvSpPr>
+        <p:spPr>
+          <a:xfrm>
+            <a:off x="6547104" y="4041648"/>
+            <a:ext cx="740664" cy="329184"/>
           </a:xfrm>
           <a:prstGeom prst="rect">
             <a:avLst/>
@@ -4220,7 +6167,7 @@
               </a:spcAft>
             </a:pPr>
             <a:r>
-              <a:rPr sz="1500" b="1">
+              <a:rPr sz="1100" b="1">
                 <a:solidFill>
                   <a:srgbClr val="0E2A47"/>
                 </a:solidFill>
@@ -4228,21 +6175,66 @@
                 <a:ea typeface="Microsoft YaHei"/>
                 <a:cs typeface="Microsoft YaHei"/>
               </a:rPr>
-              <a:t>Master</a:t>
-            </a:r>
-          </a:p>
-        </p:txBody>
-      </p:sp>
-      <p:sp>
-        <p:nvSpPr>
-          <p:cNvPr id="19" name="TextBox 18"/>
+              <a:t>新块</a:t>
+            </a:r>
+          </a:p>
+        </p:txBody>
+      </p:sp>
+      <p:sp>
+        <p:nvSpPr>
+          <p:cNvPr id="63" name="Rounded Rectangle 62"/>
+          <p:cNvSpPr/>
+          <p:nvPr/>
+        </p:nvSpPr>
+        <p:spPr>
+          <a:xfrm>
+            <a:off x="7342631" y="4041648"/>
+            <a:ext cx="740664" cy="329184"/>
+          </a:xfrm>
+          <a:prstGeom prst="roundRect">
+            <a:avLst/>
+          </a:prstGeom>
+          <a:solidFill>
+            <a:srgbClr val="FFFFFF"/>
+          </a:solidFill>
+          <a:ln w="12700">
+            <a:solidFill>
+              <a:srgbClr val="D6DCE2"/>
+            </a:solidFill>
+          </a:ln>
+        </p:spPr>
+        <p:style>
+          <a:lnRef idx="1">
+            <a:schemeClr val="accent1"/>
+          </a:lnRef>
+          <a:fillRef idx="3">
+            <a:schemeClr val="accent1"/>
+          </a:fillRef>
+          <a:effectRef idx="2">
+            <a:schemeClr val="accent1"/>
+          </a:effectRef>
+          <a:fontRef idx="minor">
+            <a:schemeClr val="lt1"/>
+          </a:fontRef>
+        </p:style>
+        <p:txBody>
+          <a:bodyPr rtlCol="0" anchor="ctr"/>
+          <a:lstStyle/>
+          <a:p>
+            <a:pPr algn="ctr"/>
+          </a:p>
+        </p:txBody>
+      </p:sp>
+      <p:sp>
+        <p:nvSpPr>
+          <p:cNvPr id="64" name="TextBox 63"/>
           <p:cNvSpPr txBox="1"/>
           <p:nvPr/>
         </p:nvSpPr>
         <p:spPr>
           <a:xfrm>
-            <a:off x="640080" y="3072384"/>
-            <a:ext cx="5120640" cy="256031"/>
+            <a:off x="7342631" y="4041648"/>
+            <a:ext cx="740664" cy="329184"/>
           </a:xfrm>
           <a:prstGeom prst="rect">
             <a:avLst/>
@@ -4250,10 +6242,181 @@
           <a:noFill/>
         </p:spPr>
         <p:txBody>
-          <a:bodyPr wrap="square" lIns="0" rIns="0" tIns="0" bIns="0" anchor="t"/>
+          <a:bodyPr wrap="square" lIns="0" rIns="0" tIns="0" bIns="0" anchor="ctr"/>
           <a:lstStyle/>
           <a:p>
             <a:pPr algn="ctr">
+              <a:spcBef>
+                <a:spcPts val="0"/>
+              </a:spcBef>
+              <a:spcAft>
+                <a:spcPts val="0"/>
+              </a:spcAft>
+            </a:pPr>
+            <a:r>
+              <a:rPr sz="1100" b="1">
+                <a:solidFill>
+                  <a:srgbClr val="0E2A47"/>
+                </a:solidFill>
+                <a:latin typeface="Microsoft YaHei"/>
+                <a:ea typeface="Microsoft YaHei"/>
+                <a:cs typeface="Microsoft YaHei"/>
+              </a:rPr>
+              <a:t>释放</a:t>
+            </a:r>
+          </a:p>
+        </p:txBody>
+      </p:sp>
+      <p:sp>
+        <p:nvSpPr>
+          <p:cNvPr id="65" name="Rounded Rectangle 64"/>
+          <p:cNvSpPr/>
+          <p:nvPr/>
+        </p:nvSpPr>
+        <p:spPr>
+          <a:xfrm>
+            <a:off x="8138160" y="4041648"/>
+            <a:ext cx="740664" cy="329184"/>
+          </a:xfrm>
+          <a:prstGeom prst="roundRect">
+            <a:avLst/>
+          </a:prstGeom>
+          <a:solidFill>
+            <a:srgbClr val="FFFFFF"/>
+          </a:solidFill>
+          <a:ln w="12700">
+            <a:solidFill>
+              <a:srgbClr val="D6DCE2"/>
+            </a:solidFill>
+          </a:ln>
+        </p:spPr>
+        <p:style>
+          <a:lnRef idx="1">
+            <a:schemeClr val="accent1"/>
+          </a:lnRef>
+          <a:fillRef idx="3">
+            <a:schemeClr val="accent1"/>
+          </a:fillRef>
+          <a:effectRef idx="2">
+            <a:schemeClr val="accent1"/>
+          </a:effectRef>
+          <a:fontRef idx="minor">
+            <a:schemeClr val="lt1"/>
+          </a:fontRef>
+        </p:style>
+        <p:txBody>
+          <a:bodyPr rtlCol="0" anchor="ctr"/>
+          <a:lstStyle/>
+          <a:p>
+            <a:pPr algn="ctr"/>
+          </a:p>
+        </p:txBody>
+      </p:sp>
+      <p:sp>
+        <p:nvSpPr>
+          <p:cNvPr id="66" name="TextBox 65"/>
+          <p:cNvSpPr txBox="1"/>
+          <p:nvPr/>
+        </p:nvSpPr>
+        <p:spPr>
+          <a:xfrm>
+            <a:off x="8138160" y="4041648"/>
+            <a:ext cx="740664" cy="329184"/>
+          </a:xfrm>
+          <a:prstGeom prst="rect">
+            <a:avLst/>
+          </a:prstGeom>
+          <a:noFill/>
+        </p:spPr>
+        <p:txBody>
+          <a:bodyPr wrap="square" lIns="0" rIns="0" tIns="0" bIns="0" anchor="ctr"/>
+          <a:lstStyle/>
+          <a:p>
+            <a:pPr algn="ctr">
+              <a:spcBef>
+                <a:spcPts val="0"/>
+              </a:spcBef>
+              <a:spcAft>
+                <a:spcPts val="0"/>
+              </a:spcAft>
+            </a:pPr>
+            <a:r>
+              <a:rPr sz="1100" b="1">
+                <a:solidFill>
+                  <a:srgbClr val="0E2A47"/>
+                </a:solidFill>
+                <a:latin typeface="Microsoft YaHei"/>
+                <a:ea typeface="Microsoft YaHei"/>
+                <a:cs typeface="Microsoft YaHei"/>
+              </a:rPr>
+              <a:t>租约</a:t>
+            </a:r>
+          </a:p>
+        </p:txBody>
+      </p:sp>
+      <p:sp>
+        <p:nvSpPr>
+          <p:cNvPr id="67" name="TextBox 66"/>
+          <p:cNvSpPr txBox="1"/>
+          <p:nvPr/>
+        </p:nvSpPr>
+        <p:spPr>
+          <a:xfrm>
+            <a:off x="8997696" y="4041648"/>
+            <a:ext cx="2560320" cy="329184"/>
+          </a:xfrm>
+          <a:prstGeom prst="rect">
+            <a:avLst/>
+          </a:prstGeom>
+          <a:noFill/>
+        </p:spPr>
+        <p:txBody>
+          <a:bodyPr wrap="square" lIns="0" rIns="0" tIns="0" bIns="0" anchor="ctr"/>
+          <a:lstStyle/>
+          <a:p>
+            <a:pPr algn="r">
+              <a:spcBef>
+                <a:spcPts val="0"/>
+              </a:spcBef>
+              <a:spcAft>
+                <a:spcPts val="0"/>
+              </a:spcAft>
+            </a:pPr>
+            <a:r>
+              <a:rPr sz="1200" b="1">
+                <a:solidFill>
+                  <a:srgbClr val="0E2A47"/>
+                </a:solidFill>
+                <a:latin typeface="Microsoft YaHei"/>
+                <a:ea typeface="Microsoft YaHei"/>
+                <a:cs typeface="Microsoft YaHei"/>
+              </a:rPr>
+              <a:t>控制面只收这三类</a:t>
+            </a:r>
+          </a:p>
+        </p:txBody>
+      </p:sp>
+      <p:sp>
+        <p:nvSpPr>
+          <p:cNvPr id="68" name="TextBox 67"/>
+          <p:cNvSpPr txBox="1"/>
+          <p:nvPr/>
+        </p:nvSpPr>
+        <p:spPr>
+          <a:xfrm>
+            <a:off x="6547104" y="4407408"/>
+            <a:ext cx="5010912" cy="256032"/>
+          </a:xfrm>
+          <a:prstGeom prst="rect">
+            <a:avLst/>
+          </a:prstGeom>
+          <a:noFill/>
+        </p:spPr>
+        <p:txBody>
+          <a:bodyPr wrap="square" lIns="0" rIns="0" tIns="0" bIns="0" anchor="ctr"/>
+          <a:lstStyle/>
+          <a:p>
+            <a:pPr algn="l">
               <a:spcBef>
                 <a:spcPts val="0"/>
               </a:spcBef>
@@ -4270,942 +6433,21 @@
                 <a:ea typeface="Microsoft YaHei"/>
                 <a:cs typeface="Microsoft YaHei"/>
               </a:rPr>
-              <a:t>查目录，分配或续租</a:t>
-            </a:r>
-          </a:p>
-        </p:txBody>
-      </p:sp>
-      <p:sp>
-        <p:nvSpPr>
-          <p:cNvPr id="20" name="Down Arrow 19"/>
+              <a:t>再问一次，返回的仍是块表里的同一行偏移和租约。</a:t>
+            </a:r>
+          </a:p>
+        </p:txBody>
+      </p:sp>
+      <p:sp>
+        <p:nvSpPr>
+          <p:cNvPr id="69" name="Rounded Rectangle 68"/>
           <p:cNvSpPr/>
           <p:nvPr/>
         </p:nvSpPr>
         <p:spPr>
           <a:xfrm>
-            <a:off x="1440180" y="3474720"/>
-            <a:ext cx="201168" cy="256032"/>
-          </a:xfrm>
-          <a:prstGeom prst="downArrow">
-            <a:avLst/>
-          </a:prstGeom>
-          <a:solidFill>
-            <a:srgbClr val="0E2A47"/>
-          </a:solidFill>
-          <a:ln>
-            <a:noFill/>
-          </a:ln>
-        </p:spPr>
-        <p:style>
-          <a:lnRef idx="1">
-            <a:schemeClr val="accent1"/>
-          </a:lnRef>
-          <a:fillRef idx="3">
-            <a:schemeClr val="accent1"/>
-          </a:fillRef>
-          <a:effectRef idx="2">
-            <a:schemeClr val="accent1"/>
-          </a:effectRef>
-          <a:fontRef idx="minor">
-            <a:schemeClr val="lt1"/>
-          </a:fontRef>
-        </p:style>
-        <p:txBody>
-          <a:bodyPr rtlCol="0" anchor="ctr"/>
-          <a:lstStyle/>
-          <a:p>
-            <a:pPr algn="ctr"/>
-          </a:p>
-        </p:txBody>
-      </p:sp>
-      <p:sp>
-        <p:nvSpPr>
-          <p:cNvPr id="21" name="TextBox 20"/>
-          <p:cNvSpPr txBox="1"/>
-          <p:nvPr/>
-        </p:nvSpPr>
-        <p:spPr>
-          <a:xfrm>
-            <a:off x="1714500" y="3401568"/>
-            <a:ext cx="3246120" cy="402336"/>
-          </a:xfrm>
-          <a:prstGeom prst="rect">
-            <a:avLst/>
-          </a:prstGeom>
-          <a:noFill/>
-        </p:spPr>
-        <p:txBody>
-          <a:bodyPr wrap="square" lIns="0" rIns="0" tIns="0" bIns="0" anchor="ctr"/>
-          <a:lstStyle/>
-          <a:p>
-            <a:pPr algn="l">
-              <a:spcBef>
-                <a:spcPts val="0"/>
-              </a:spcBef>
-              <a:spcAft>
-                <a:spcPts val="0"/>
-              </a:spcAft>
-            </a:pPr>
-            <a:r>
-              <a:rPr sz="1300" b="1">
-                <a:solidFill>
-                  <a:srgbClr val="0E2A47"/>
-                </a:solidFill>
-                <a:latin typeface="Microsoft YaHei"/>
-                <a:ea typeface="Microsoft YaHei"/>
-                <a:cs typeface="Microsoft YaHei"/>
-              </a:rPr>
-              <a:t>池内偏移，长度，租约</a:t>
-            </a:r>
-          </a:p>
-        </p:txBody>
-      </p:sp>
-      <p:sp>
-        <p:nvSpPr>
-          <p:cNvPr id="22" name="Rounded Rectangle 21"/>
-          <p:cNvSpPr/>
-          <p:nvPr/>
-        </p:nvSpPr>
-        <p:spPr>
-          <a:xfrm>
-            <a:off x="530352" y="3822191"/>
-            <a:ext cx="5340096" cy="658368"/>
-          </a:xfrm>
-          <a:prstGeom prst="roundRect">
-            <a:avLst/>
-          </a:prstGeom>
-          <a:solidFill>
-            <a:srgbClr val="F4F7FA"/>
-          </a:solidFill>
-          <a:ln w="12700">
-            <a:solidFill>
-              <a:srgbClr val="D6DCE2"/>
-            </a:solidFill>
-          </a:ln>
-        </p:spPr>
-        <p:style>
-          <a:lnRef idx="1">
-            <a:schemeClr val="accent1"/>
-          </a:lnRef>
-          <a:fillRef idx="3">
-            <a:schemeClr val="accent1"/>
-          </a:fillRef>
-          <a:effectRef idx="2">
-            <a:schemeClr val="accent1"/>
-          </a:effectRef>
-          <a:fontRef idx="minor">
-            <a:schemeClr val="lt1"/>
-          </a:fontRef>
-        </p:style>
-        <p:txBody>
-          <a:bodyPr rtlCol="0" anchor="ctr"/>
-          <a:lstStyle/>
-          <a:p>
-            <a:pPr algn="ctr"/>
-          </a:p>
-        </p:txBody>
-      </p:sp>
-      <p:sp>
-        <p:nvSpPr>
-          <p:cNvPr id="23" name="TextBox 22"/>
-          <p:cNvSpPr txBox="1"/>
-          <p:nvPr/>
-        </p:nvSpPr>
-        <p:spPr>
-          <a:xfrm>
-            <a:off x="640080" y="3877055"/>
-            <a:ext cx="5120640" cy="292608"/>
-          </a:xfrm>
-          <a:prstGeom prst="rect">
-            <a:avLst/>
-          </a:prstGeom>
-          <a:noFill/>
-        </p:spPr>
-        <p:txBody>
-          <a:bodyPr wrap="square" lIns="0" rIns="0" tIns="0" bIns="0" anchor="ctr"/>
-          <a:lstStyle/>
-          <a:p>
-            <a:pPr algn="ctr">
-              <a:spcBef>
-                <a:spcPts val="0"/>
-              </a:spcBef>
-              <a:spcAft>
-                <a:spcPts val="0"/>
-              </a:spcAft>
-            </a:pPr>
-            <a:r>
-              <a:rPr sz="1500" b="1">
-                <a:solidFill>
-                  <a:srgbClr val="0E2A47"/>
-                </a:solidFill>
-                <a:latin typeface="Microsoft YaHei"/>
-                <a:ea typeface="Microsoft YaHei"/>
-                <a:cs typeface="Microsoft YaHei"/>
-              </a:rPr>
-              <a:t>Decode 卡</a:t>
-            </a:r>
-          </a:p>
-        </p:txBody>
-      </p:sp>
-      <p:sp>
-        <p:nvSpPr>
-          <p:cNvPr id="24" name="TextBox 23"/>
-          <p:cNvSpPr txBox="1"/>
-          <p:nvPr/>
-        </p:nvSpPr>
-        <p:spPr>
-          <a:xfrm>
-            <a:off x="640080" y="4151376"/>
-            <a:ext cx="5120640" cy="256031"/>
-          </a:xfrm>
-          <a:prstGeom prst="rect">
-            <a:avLst/>
-          </a:prstGeom>
-          <a:noFill/>
-        </p:spPr>
-        <p:txBody>
-          <a:bodyPr wrap="square" lIns="0" rIns="0" tIns="0" bIns="0" anchor="t"/>
-          <a:lstStyle/>
-          <a:p>
-            <a:pPr algn="ctr">
-              <a:spcBef>
-                <a:spcPts val="0"/>
-              </a:spcBef>
-              <a:spcAft>
-                <a:spcPts val="0"/>
-              </a:spcAft>
-            </a:pPr>
-            <a:r>
-              <a:rPr sz="1200" b="0">
-                <a:solidFill>
-                  <a:srgbClr val="1C242E"/>
-                </a:solidFill>
-                <a:latin typeface="Microsoft YaHei"/>
-                <a:ea typeface="Microsoft YaHei"/>
-                <a:cs typeface="Microsoft YaHei"/>
-              </a:rPr>
-              <a:t>拿到地址后才发 DMA</a:t>
-            </a:r>
-          </a:p>
-        </p:txBody>
-      </p:sp>
-      <p:sp>
-        <p:nvSpPr>
-          <p:cNvPr id="25" name="Down Arrow 24"/>
-          <p:cNvSpPr/>
-          <p:nvPr/>
-        </p:nvSpPr>
-        <p:spPr>
-          <a:xfrm>
-            <a:off x="1440180" y="4553712"/>
-            <a:ext cx="201168" cy="256032"/>
-          </a:xfrm>
-          <a:prstGeom prst="downArrow">
-            <a:avLst/>
-          </a:prstGeom>
-          <a:solidFill>
-            <a:srgbClr val="0E7A76"/>
-          </a:solidFill>
-          <a:ln>
-            <a:noFill/>
-          </a:ln>
-        </p:spPr>
-        <p:style>
-          <a:lnRef idx="1">
-            <a:schemeClr val="accent1"/>
-          </a:lnRef>
-          <a:fillRef idx="3">
-            <a:schemeClr val="accent1"/>
-          </a:fillRef>
-          <a:effectRef idx="2">
-            <a:schemeClr val="accent1"/>
-          </a:effectRef>
-          <a:fontRef idx="minor">
-            <a:schemeClr val="lt1"/>
-          </a:fontRef>
-        </p:style>
-        <p:txBody>
-          <a:bodyPr rtlCol="0" anchor="ctr"/>
-          <a:lstStyle/>
-          <a:p>
-            <a:pPr algn="ctr"/>
-          </a:p>
-        </p:txBody>
-      </p:sp>
-      <p:sp>
-        <p:nvSpPr>
-          <p:cNvPr id="26" name="TextBox 25"/>
-          <p:cNvSpPr txBox="1"/>
-          <p:nvPr/>
-        </p:nvSpPr>
-        <p:spPr>
-          <a:xfrm>
-            <a:off x="1714500" y="4480560"/>
-            <a:ext cx="3246120" cy="402336"/>
-          </a:xfrm>
-          <a:prstGeom prst="rect">
-            <a:avLst/>
-          </a:prstGeom>
-          <a:noFill/>
-        </p:spPr>
-        <p:txBody>
-          <a:bodyPr wrap="square" lIns="0" rIns="0" tIns="0" bIns="0" anchor="ctr"/>
-          <a:lstStyle/>
-          <a:p>
-            <a:pPr algn="l">
-              <a:spcBef>
-                <a:spcPts val="0"/>
-              </a:spcBef>
-              <a:spcAft>
-                <a:spcPts val="0"/>
-              </a:spcAft>
-            </a:pPr>
-            <a:r>
-              <a:rPr sz="1300" b="1">
-                <a:solidFill>
-                  <a:srgbClr val="0E7A76"/>
-                </a:solidFill>
-                <a:latin typeface="Microsoft YaHei"/>
-                <a:ea typeface="Microsoft YaHei"/>
-                <a:cs typeface="Microsoft YaHei"/>
-              </a:rPr>
-              <a:t>KV 字节，走总线</a:t>
-            </a:r>
-          </a:p>
-        </p:txBody>
-      </p:sp>
-      <p:sp>
-        <p:nvSpPr>
-          <p:cNvPr id="27" name="Rounded Rectangle 26"/>
-          <p:cNvSpPr/>
-          <p:nvPr/>
-        </p:nvSpPr>
-        <p:spPr>
-          <a:xfrm>
-            <a:off x="530352" y="4901184"/>
-            <a:ext cx="5340096" cy="658368"/>
-          </a:xfrm>
-          <a:prstGeom prst="roundRect">
-            <a:avLst/>
-          </a:prstGeom>
-          <a:solidFill>
-            <a:srgbClr val="E7F3F2"/>
-          </a:solidFill>
-          <a:ln w="12700">
-            <a:solidFill>
-              <a:srgbClr val="D6DCE2"/>
-            </a:solidFill>
-          </a:ln>
-        </p:spPr>
-        <p:style>
-          <a:lnRef idx="1">
-            <a:schemeClr val="accent1"/>
-          </a:lnRef>
-          <a:fillRef idx="3">
-            <a:schemeClr val="accent1"/>
-          </a:fillRef>
-          <a:effectRef idx="2">
-            <a:schemeClr val="accent1"/>
-          </a:effectRef>
-          <a:fontRef idx="minor">
-            <a:schemeClr val="lt1"/>
-          </a:fontRef>
-        </p:style>
-        <p:txBody>
-          <a:bodyPr rtlCol="0" anchor="ctr"/>
-          <a:lstStyle/>
-          <a:p>
-            <a:pPr algn="ctr"/>
-          </a:p>
-        </p:txBody>
-      </p:sp>
-      <p:sp>
-        <p:nvSpPr>
-          <p:cNvPr id="28" name="TextBox 27"/>
-          <p:cNvSpPr txBox="1"/>
-          <p:nvPr/>
-        </p:nvSpPr>
-        <p:spPr>
-          <a:xfrm>
-            <a:off x="640080" y="4956048"/>
-            <a:ext cx="5120640" cy="292608"/>
-          </a:xfrm>
-          <a:prstGeom prst="rect">
-            <a:avLst/>
-          </a:prstGeom>
-          <a:noFill/>
-        </p:spPr>
-        <p:txBody>
-          <a:bodyPr wrap="square" lIns="0" rIns="0" tIns="0" bIns="0" anchor="ctr"/>
-          <a:lstStyle/>
-          <a:p>
-            <a:pPr algn="ctr">
-              <a:spcBef>
-                <a:spcPts val="0"/>
-              </a:spcBef>
-              <a:spcAft>
-                <a:spcPts val="0"/>
-              </a:spcAft>
-            </a:pPr>
-            <a:r>
-              <a:rPr sz="1500" b="1">
-                <a:solidFill>
-                  <a:srgbClr val="0E7A76"/>
-                </a:solidFill>
-                <a:latin typeface="Microsoft YaHei"/>
-                <a:ea typeface="Microsoft YaHei"/>
-                <a:cs typeface="Microsoft YaHei"/>
-              </a:rPr>
-              <a:t>DDR 池</a:t>
-            </a:r>
-          </a:p>
-        </p:txBody>
-      </p:sp>
-      <p:sp>
-        <p:nvSpPr>
-          <p:cNvPr id="29" name="TextBox 28"/>
-          <p:cNvSpPr txBox="1"/>
-          <p:nvPr/>
-        </p:nvSpPr>
-        <p:spPr>
-          <a:xfrm>
-            <a:off x="640080" y="5230368"/>
-            <a:ext cx="5120640" cy="256031"/>
-          </a:xfrm>
-          <a:prstGeom prst="rect">
-            <a:avLst/>
-          </a:prstGeom>
-          <a:noFill/>
-        </p:spPr>
-        <p:txBody>
-          <a:bodyPr wrap="square" lIns="0" rIns="0" tIns="0" bIns="0" anchor="t"/>
-          <a:lstStyle/>
-          <a:p>
-            <a:pPr algn="ctr">
-              <a:spcBef>
-                <a:spcPts val="0"/>
-              </a:spcBef>
-              <a:spcAft>
-                <a:spcPts val="0"/>
-              </a:spcAft>
-            </a:pPr>
-            <a:r>
-              <a:rPr sz="1200" b="0">
-                <a:solidFill>
-                  <a:srgbClr val="1C242E"/>
-                </a:solidFill>
-                <a:latin typeface="Microsoft YaHei"/>
-                <a:ea typeface="Microsoft YaHei"/>
-                <a:cs typeface="Microsoft YaHei"/>
-              </a:rPr>
-              <a:t>按偏移读写这块 KV</a:t>
-            </a:r>
-          </a:p>
-        </p:txBody>
-      </p:sp>
-      <p:sp>
-        <p:nvSpPr>
-          <p:cNvPr id="30" name="Rounded Rectangle 29"/>
-          <p:cNvSpPr/>
-          <p:nvPr/>
-        </p:nvSpPr>
-        <p:spPr>
-          <a:xfrm>
-            <a:off x="6327648" y="1664208"/>
-            <a:ext cx="5340096" cy="841248"/>
-          </a:xfrm>
-          <a:prstGeom prst="roundRect">
-            <a:avLst/>
-          </a:prstGeom>
-          <a:solidFill>
-            <a:srgbClr val="E7F3F2"/>
-          </a:solidFill>
-          <a:ln w="12700">
-            <a:solidFill>
-              <a:srgbClr val="D6DCE2"/>
-            </a:solidFill>
-          </a:ln>
-        </p:spPr>
-        <p:style>
-          <a:lnRef idx="1">
-            <a:schemeClr val="accent1"/>
-          </a:lnRef>
-          <a:fillRef idx="3">
-            <a:schemeClr val="accent1"/>
-          </a:fillRef>
-          <a:effectRef idx="2">
-            <a:schemeClr val="accent1"/>
-          </a:effectRef>
-          <a:fontRef idx="minor">
-            <a:schemeClr val="lt1"/>
-          </a:fontRef>
-        </p:style>
-        <p:txBody>
-          <a:bodyPr rtlCol="0" anchor="ctr"/>
-          <a:lstStyle/>
-          <a:p>
-            <a:pPr algn="ctr"/>
-          </a:p>
-        </p:txBody>
-      </p:sp>
-      <p:sp>
-        <p:nvSpPr>
-          <p:cNvPr id="31" name="TextBox 30"/>
-          <p:cNvSpPr txBox="1"/>
-          <p:nvPr/>
-        </p:nvSpPr>
-        <p:spPr>
-          <a:xfrm>
-            <a:off x="6437376" y="1719072"/>
-            <a:ext cx="5120640" cy="292608"/>
-          </a:xfrm>
-          <a:prstGeom prst="rect">
-            <a:avLst/>
-          </a:prstGeom>
-          <a:noFill/>
-        </p:spPr>
-        <p:txBody>
-          <a:bodyPr wrap="square" lIns="0" rIns="0" tIns="0" bIns="0" anchor="ctr"/>
-          <a:lstStyle/>
-          <a:p>
-            <a:pPr algn="ctr">
-              <a:spcBef>
-                <a:spcPts val="0"/>
-              </a:spcBef>
-              <a:spcAft>
-                <a:spcPts val="0"/>
-              </a:spcAft>
-            </a:pPr>
-            <a:r>
-              <a:rPr sz="1500" b="1">
-                <a:solidFill>
-                  <a:srgbClr val="0E7A76"/>
-                </a:solidFill>
-                <a:latin typeface="Microsoft YaHei"/>
-                <a:ea typeface="Microsoft YaHei"/>
-                <a:cs typeface="Microsoft YaHei"/>
-              </a:rPr>
-              <a:t>Decode 卡 · 块表</a:t>
-            </a:r>
-          </a:p>
-        </p:txBody>
-      </p:sp>
-      <p:sp>
-        <p:nvSpPr>
-          <p:cNvPr id="32" name="TextBox 31"/>
-          <p:cNvSpPr txBox="1"/>
-          <p:nvPr/>
-        </p:nvSpPr>
-        <p:spPr>
-          <a:xfrm>
-            <a:off x="6437376" y="1993392"/>
-            <a:ext cx="5120640" cy="438912"/>
-          </a:xfrm>
-          <a:prstGeom prst="rect">
-            <a:avLst/>
-          </a:prstGeom>
-          <a:noFill/>
-        </p:spPr>
-        <p:txBody>
-          <a:bodyPr wrap="square" lIns="0" rIns="0" tIns="0" bIns="0" anchor="t"/>
-          <a:lstStyle/>
-          <a:p>
-            <a:pPr algn="ctr">
-              <a:spcBef>
-                <a:spcPts val="0"/>
-              </a:spcBef>
-              <a:spcAft>
-                <a:spcPts val="0"/>
-              </a:spcAft>
-            </a:pPr>
-            <a:r>
-              <a:rPr sz="1200" b="0">
-                <a:solidFill>
-                  <a:srgbClr val="1C242E"/>
-                </a:solidFill>
-                <a:latin typeface="Microsoft YaHei"/>
-                <a:ea typeface="Microsoft YaHei"/>
-                <a:cs typeface="Microsoft YaHei"/>
-              </a:rPr>
-              <a:t>已有池内偏移、长度和租约</a:t>
-            </a:r>
-          </a:p>
-        </p:txBody>
-      </p:sp>
-      <p:sp>
-        <p:nvSpPr>
-          <p:cNvPr id="33" name="Down Arrow 32"/>
-          <p:cNvSpPr/>
-          <p:nvPr/>
-        </p:nvSpPr>
-        <p:spPr>
-          <a:xfrm>
-            <a:off x="7237476" y="2615184"/>
-            <a:ext cx="201168" cy="256032"/>
-          </a:xfrm>
-          <a:prstGeom prst="downArrow">
-            <a:avLst/>
-          </a:prstGeom>
-          <a:solidFill>
-            <a:srgbClr val="0E7A76"/>
-          </a:solidFill>
-          <a:ln>
-            <a:noFill/>
-          </a:ln>
-        </p:spPr>
-        <p:style>
-          <a:lnRef idx="1">
-            <a:schemeClr val="accent1"/>
-          </a:lnRef>
-          <a:fillRef idx="3">
-            <a:schemeClr val="accent1"/>
-          </a:fillRef>
-          <a:effectRef idx="2">
-            <a:schemeClr val="accent1"/>
-          </a:effectRef>
-          <a:fontRef idx="minor">
-            <a:schemeClr val="lt1"/>
-          </a:fontRef>
-        </p:style>
-        <p:txBody>
-          <a:bodyPr rtlCol="0" anchor="ctr"/>
-          <a:lstStyle/>
-          <a:p>
-            <a:pPr algn="ctr"/>
-          </a:p>
-        </p:txBody>
-      </p:sp>
-      <p:sp>
-        <p:nvSpPr>
-          <p:cNvPr id="34" name="TextBox 33"/>
-          <p:cNvSpPr txBox="1"/>
-          <p:nvPr/>
-        </p:nvSpPr>
-        <p:spPr>
-          <a:xfrm>
-            <a:off x="7511796" y="2542032"/>
-            <a:ext cx="3246120" cy="402336"/>
-          </a:xfrm>
-          <a:prstGeom prst="rect">
-            <a:avLst/>
-          </a:prstGeom>
-          <a:noFill/>
-        </p:spPr>
-        <p:txBody>
-          <a:bodyPr wrap="square" lIns="0" rIns="0" tIns="0" bIns="0" anchor="ctr"/>
-          <a:lstStyle/>
-          <a:p>
-            <a:pPr algn="l">
-              <a:spcBef>
-                <a:spcPts val="0"/>
-              </a:spcBef>
-              <a:spcAft>
-                <a:spcPts val="0"/>
-              </a:spcAft>
-            </a:pPr>
-            <a:r>
-              <a:rPr sz="1300" b="1">
-                <a:solidFill>
-                  <a:srgbClr val="0E7A76"/>
-                </a:solidFill>
-                <a:latin typeface="Microsoft YaHei"/>
-                <a:ea typeface="Microsoft YaHei"/>
-                <a:cs typeface="Microsoft YaHei"/>
-              </a:rPr>
-              <a:t>KV 字节，走总线</a:t>
-            </a:r>
-          </a:p>
-        </p:txBody>
-      </p:sp>
-      <p:sp>
-        <p:nvSpPr>
-          <p:cNvPr id="35" name="Rounded Rectangle 34"/>
-          <p:cNvSpPr/>
-          <p:nvPr/>
-        </p:nvSpPr>
-        <p:spPr>
-          <a:xfrm>
-            <a:off x="6327648" y="2980944"/>
-            <a:ext cx="5340096" cy="768096"/>
-          </a:xfrm>
-          <a:prstGeom prst="roundRect">
-            <a:avLst/>
-          </a:prstGeom>
-          <a:solidFill>
-            <a:srgbClr val="E7F3F2"/>
-          </a:solidFill>
-          <a:ln w="12700">
-            <a:solidFill>
-              <a:srgbClr val="D6DCE2"/>
-            </a:solidFill>
-          </a:ln>
-        </p:spPr>
-        <p:style>
-          <a:lnRef idx="1">
-            <a:schemeClr val="accent1"/>
-          </a:lnRef>
-          <a:fillRef idx="3">
-            <a:schemeClr val="accent1"/>
-          </a:fillRef>
-          <a:effectRef idx="2">
-            <a:schemeClr val="accent1"/>
-          </a:effectRef>
-          <a:fontRef idx="minor">
-            <a:schemeClr val="lt1"/>
-          </a:fontRef>
-        </p:style>
-        <p:txBody>
-          <a:bodyPr rtlCol="0" anchor="ctr"/>
-          <a:lstStyle/>
-          <a:p>
-            <a:pPr algn="ctr"/>
-          </a:p>
-        </p:txBody>
-      </p:sp>
-      <p:sp>
-        <p:nvSpPr>
-          <p:cNvPr id="36" name="TextBox 35"/>
-          <p:cNvSpPr txBox="1"/>
-          <p:nvPr/>
-        </p:nvSpPr>
-        <p:spPr>
-          <a:xfrm>
-            <a:off x="6437376" y="3035808"/>
-            <a:ext cx="5120640" cy="292608"/>
-          </a:xfrm>
-          <a:prstGeom prst="rect">
-            <a:avLst/>
-          </a:prstGeom>
-          <a:noFill/>
-        </p:spPr>
-        <p:txBody>
-          <a:bodyPr wrap="square" lIns="0" rIns="0" tIns="0" bIns="0" anchor="ctr"/>
-          <a:lstStyle/>
-          <a:p>
-            <a:pPr algn="ctr">
-              <a:spcBef>
-                <a:spcPts val="0"/>
-              </a:spcBef>
-              <a:spcAft>
-                <a:spcPts val="0"/>
-              </a:spcAft>
-            </a:pPr>
-            <a:r>
-              <a:rPr sz="1500" b="1">
-                <a:solidFill>
-                  <a:srgbClr val="0E7A76"/>
-                </a:solidFill>
-                <a:latin typeface="Microsoft YaHei"/>
-                <a:ea typeface="Microsoft YaHei"/>
-                <a:cs typeface="Microsoft YaHei"/>
-              </a:rPr>
-              <a:t>DDR 池</a:t>
-            </a:r>
-          </a:p>
-        </p:txBody>
-      </p:sp>
-      <p:sp>
-        <p:nvSpPr>
-          <p:cNvPr id="37" name="TextBox 36"/>
-          <p:cNvSpPr txBox="1"/>
-          <p:nvPr/>
-        </p:nvSpPr>
-        <p:spPr>
-          <a:xfrm>
-            <a:off x="6437376" y="3310127"/>
-            <a:ext cx="5120640" cy="365759"/>
-          </a:xfrm>
-          <a:prstGeom prst="rect">
-            <a:avLst/>
-          </a:prstGeom>
-          <a:noFill/>
-        </p:spPr>
-        <p:txBody>
-          <a:bodyPr wrap="square" lIns="0" rIns="0" tIns="0" bIns="0" anchor="t"/>
-          <a:lstStyle/>
-          <a:p>
-            <a:pPr algn="ctr">
-              <a:spcBef>
-                <a:spcPts val="0"/>
-              </a:spcBef>
-              <a:spcAft>
-                <a:spcPts val="0"/>
-              </a:spcAft>
-            </a:pPr>
-            <a:r>
-              <a:rPr sz="1200" b="0">
-                <a:solidFill>
-                  <a:srgbClr val="1C242E"/>
-                </a:solidFill>
-                <a:latin typeface="Microsoft YaHei"/>
-                <a:ea typeface="Microsoft YaHei"/>
-                <a:cs typeface="Microsoft YaHei"/>
-              </a:rPr>
-              <a:t>按块表里的偏移读写</a:t>
-            </a:r>
-          </a:p>
-        </p:txBody>
-      </p:sp>
-      <p:sp>
-        <p:nvSpPr>
-          <p:cNvPr id="38" name="Rounded Rectangle 37"/>
-          <p:cNvSpPr/>
-          <p:nvPr/>
-        </p:nvSpPr>
-        <p:spPr>
-          <a:xfrm>
-            <a:off x="6327648" y="3895344"/>
-            <a:ext cx="5340096" cy="1664208"/>
-          </a:xfrm>
-          <a:prstGeom prst="roundRect">
-            <a:avLst/>
-          </a:prstGeom>
-          <a:solidFill>
-            <a:srgbClr val="F4F7FA"/>
-          </a:solidFill>
-          <a:ln w="12700">
-            <a:solidFill>
-              <a:srgbClr val="D6DCE2"/>
-            </a:solidFill>
-          </a:ln>
-        </p:spPr>
-        <p:style>
-          <a:lnRef idx="1">
-            <a:schemeClr val="accent1"/>
-          </a:lnRef>
-          <a:fillRef idx="3">
-            <a:schemeClr val="accent1"/>
-          </a:fillRef>
-          <a:effectRef idx="2">
-            <a:schemeClr val="accent1"/>
-          </a:effectRef>
-          <a:fontRef idx="minor">
-            <a:schemeClr val="lt1"/>
-          </a:fontRef>
-        </p:style>
-        <p:txBody>
-          <a:bodyPr rtlCol="0" anchor="ctr"/>
-          <a:lstStyle/>
-          <a:p>
-            <a:pPr algn="ctr"/>
-          </a:p>
-        </p:txBody>
-      </p:sp>
-      <p:sp>
-        <p:nvSpPr>
-          <p:cNvPr id="39" name="TextBox 38"/>
-          <p:cNvSpPr txBox="1"/>
-          <p:nvPr/>
-        </p:nvSpPr>
-        <p:spPr>
-          <a:xfrm>
-            <a:off x="6473952" y="3986784"/>
-            <a:ext cx="5047488" cy="292608"/>
-          </a:xfrm>
-          <a:prstGeom prst="rect">
-            <a:avLst/>
-          </a:prstGeom>
-          <a:noFill/>
-        </p:spPr>
-        <p:txBody>
-          <a:bodyPr wrap="square" lIns="0" rIns="0" tIns="0" bIns="0" anchor="ctr"/>
-          <a:lstStyle/>
-          <a:p>
-            <a:pPr algn="ctr">
-              <a:spcBef>
-                <a:spcPts val="0"/>
-              </a:spcBef>
-              <a:spcAft>
-                <a:spcPts val="0"/>
-              </a:spcAft>
-            </a:pPr>
-            <a:r>
-              <a:rPr sz="1500" b="1">
-                <a:solidFill>
-                  <a:srgbClr val="5A636E"/>
-                </a:solidFill>
-                <a:latin typeface="Microsoft YaHei"/>
-                <a:ea typeface="Microsoft YaHei"/>
-                <a:cs typeface="Microsoft YaHei"/>
-              </a:rPr>
-              <a:t>Master</a:t>
-            </a:r>
-          </a:p>
-        </p:txBody>
-      </p:sp>
-      <p:sp>
-        <p:nvSpPr>
-          <p:cNvPr id="40" name="TextBox 39"/>
-          <p:cNvSpPr txBox="1"/>
-          <p:nvPr/>
-        </p:nvSpPr>
-        <p:spPr>
-          <a:xfrm>
-            <a:off x="6510528" y="4315968"/>
-            <a:ext cx="4974336" cy="1097280"/>
-          </a:xfrm>
-          <a:prstGeom prst="rect">
-            <a:avLst/>
-          </a:prstGeom>
-          <a:noFill/>
-        </p:spPr>
-        <p:txBody>
-          <a:bodyPr wrap="square" lIns="0" rIns="0" tIns="0" bIns="0" anchor="t"/>
-          <a:lstStyle/>
-          <a:p>
-            <a:pPr algn="ctr">
-              <a:spcBef>
-                <a:spcPts val="0"/>
-              </a:spcBef>
-              <a:spcAft>
-                <a:spcPts val="0"/>
-              </a:spcAft>
-            </a:pPr>
-            <a:r>
-              <a:rPr sz="1400" b="0">
-                <a:solidFill>
-                  <a:srgbClr val="1C242E"/>
-                </a:solidFill>
-                <a:latin typeface="Microsoft YaHei"/>
-                <a:ea typeface="Microsoft YaHei"/>
-                <a:cs typeface="Microsoft YaHei"/>
-              </a:rPr>
-              <a:t>这次没有消息。租约未到期，块也未被释放。</a:t>
-            </a:r>
-          </a:p>
-          <a:p>
-            <a:pPr algn="ctr">
-              <a:spcBef>
-                <a:spcPts val="0"/>
-              </a:spcBef>
-              <a:spcAft>
-                <a:spcPts val="0"/>
-              </a:spcAft>
-            </a:pPr>
-            <a:r>
-              <a:rPr sz="1400" b="0">
-                <a:solidFill>
-                  <a:srgbClr val="1C242E"/>
-                </a:solidFill>
-                <a:latin typeface="Microsoft YaHei"/>
-                <a:ea typeface="Microsoft YaHei"/>
-                <a:cs typeface="Microsoft YaHei"/>
-              </a:rPr>
-              <a:t>再问一次，返回的仍是块表里的同一行。</a:t>
-            </a:r>
-          </a:p>
-        </p:txBody>
-      </p:sp>
-      <p:sp>
-        <p:nvSpPr>
-          <p:cNvPr id="41" name="Rounded Rectangle 40"/>
-          <p:cNvSpPr/>
-          <p:nvPr/>
-        </p:nvSpPr>
-        <p:spPr>
-          <a:xfrm>
-            <a:off x="384048" y="5907024"/>
-            <a:ext cx="11430000" cy="603504"/>
+            <a:off x="365760" y="4901184"/>
+            <a:ext cx="11466576" cy="1536192"/>
           </a:xfrm>
           <a:prstGeom prst="roundRect">
             <a:avLst/>
@@ -5241,14 +6483,14 @@
       </p:sp>
       <p:sp>
         <p:nvSpPr>
-          <p:cNvPr id="42" name="TextBox 41"/>
+          <p:cNvPr id="70" name="TextBox 69"/>
           <p:cNvSpPr txBox="1"/>
           <p:nvPr/>
         </p:nvSpPr>
         <p:spPr>
           <a:xfrm>
-            <a:off x="512064" y="5907024"/>
-            <a:ext cx="11173968" cy="603504"/>
+            <a:off x="512064" y="4992624"/>
+            <a:ext cx="11173968" cy="1353312"/>
           </a:xfrm>
           <a:prstGeom prst="rect">
             <a:avLst/>
@@ -5268,7 +6510,7 @@
               </a:spcAft>
             </a:pPr>
             <a:r>
-              <a:rPr sz="1300" b="0">
+              <a:rPr sz="1400" b="0">
                 <a:solidFill>
                   <a:srgbClr val="7A541C"/>
                 </a:solidFill>
@@ -5276,7 +6518,7 @@
                 <a:ea typeface="Microsoft YaHei"/>
                 <a:cs typeface="Microsoft YaHei"/>
               </a:rPr>
-              <a:t>有必要再问的时机：新块第一次进池、块从池中释放、租约到期。</a:t>
+              <a:t>AS-IS：每次 swap 经控制面入队。入队是块 id、字节数、换入或换出。出队是池内偏移、长度、租约。</a:t>
             </a:r>
           </a:p>
           <a:p>
@@ -5289,7 +6531,7 @@
               </a:spcAft>
             </a:pPr>
             <a:r>
-              <a:rPr sz="1300" b="0">
+              <a:rPr sz="1400" b="0">
                 <a:solidFill>
                   <a:srgbClr val="7A541C"/>
                 </a:solidFill>
@@ -5297,20 +6539,41 @@
                 <a:ea typeface="Microsoft YaHei"/>
                 <a:cs typeface="Microsoft YaHei"/>
               </a:rPr>
-              <a:t>一块 4 MB、总线 64 GB/s 时 DMA 约 0.06 ms。一次往返按 0.2 ms 计，多卡排队后更长，先于总线饱和。</a:t>
-            </a:r>
-          </a:p>
-        </p:txBody>
-      </p:sp>
-      <p:sp>
-        <p:nvSpPr>
-          <p:cNvPr id="43" name="Rectangle 42"/>
+              <a:t>总线 DMA 在出队之后。4 MB、64 GB/s 时约 0.06 ms；往返按 0.2 ms，多卡排队后控制面先饱和。</a:t>
+            </a:r>
+          </a:p>
+          <a:p>
+            <a:pPr algn="l">
+              <a:spcBef>
+                <a:spcPts val="0"/>
+              </a:spcBef>
+              <a:spcAft>
+                <a:spcPts val="0"/>
+              </a:spcAft>
+            </a:pPr>
+            <a:r>
+              <a:rPr sz="1400" b="0">
+                <a:solidFill>
+                  <a:srgbClr val="7A541C"/>
+                </a:solidFill>
+                <a:latin typeface="Microsoft YaHei"/>
+                <a:ea typeface="Microsoft YaHei"/>
+                <a:cs typeface="Microsoft YaHei"/>
+              </a:rPr>
+              <a:t>TO-BE：偏移和租约留在卡上。热路径只有总线。Master 只在新块进池、块释放、租约到期时出现。</a:t>
+            </a:r>
+          </a:p>
+        </p:txBody>
+      </p:sp>
+      <p:sp>
+        <p:nvSpPr>
+          <p:cNvPr id="71" name="Rectangle 70"/>
           <p:cNvSpPr/>
           <p:nvPr/>
         </p:nvSpPr>
         <p:spPr>
           <a:xfrm>
-            <a:off x="384048" y="6583680"/>
+            <a:off x="384048" y="6565392"/>
             <a:ext cx="11430000" cy="9144"/>
           </a:xfrm>
           <a:prstGeom prst="rect">
@@ -5347,7 +6610,7 @@
       </p:sp>
       <p:sp>
         <p:nvSpPr>
-          <p:cNvPr id="44" name="TextBox 43"/>
+          <p:cNvPr id="72" name="TextBox 71"/>
           <p:cNvSpPr txBox="1"/>
           <p:nvPr/>
         </p:nvSpPr>
@@ -5382,7 +6645,7 @@
                 <a:ea typeface="Microsoft YaHei"/>
                 <a:cs typeface="Microsoft YaHei"/>
               </a:rPr>
-              <a:t>跨卡共享的 DDR 池才设 Master    ·    单机进程内的 host DDR 块表不走这跳    ·    0.06 ms / 0.2 ms 是估算量级</a:t>
+              <a:t>跨卡共享的 DDR 池才有左侧 Master    ·    单机进程内的 host DDR 块表走右侧    ·    0.06 ms / 0.2 ms 为估算</a:t>
             </a:r>
           </a:p>
         </p:txBody>

</xml_diff>